<commit_message>
Apresentação em linguagem de gestor: gráficos nativos, autor e fonte dos dados
- Gráficos técnicos (explicação do município cearense, efeito por estado,
  choques estaduais, variáveis) refeitos como gráficos nativos com nomes
  legíveis e escala relativa, sem SHAP, AUC ou log-odds
- Mapas de risco e de grupos sem eixos de latitude/longitude
- Autor na capa, fonte dos dados no rodapé de cada slide e texto
  alternativo descritivo nas imagens
- O exemplo do Ceará é identificado como o caso extremo da amostra
- Falas mais curtas nos slides densos (~3min40s de fala)
</commit_message>
<xml_diff>
--- a/reports/apresentacao_executiva.pptx
+++ b/reports/apresentacao_executiva.pptx
@@ -456,7 +456,7 @@
                 </a:solidFill>
                 <a:latin typeface="Calibri"/>
               </a:rPr>
-              <a:t>Peso de cada tema na previsão (SHAP agregado, % do total)</a:t>
+              <a:t>Peso de cada tema na previsão do modelo (% do total)</a:t>
             </a:r>
           </a:p>
         </c:rich>
@@ -483,8 +483,10 @@
               </c:strCache>
             </c:strRef>
           </c:tx>
+          <c:invertIfNegative val="0"/>
           <c:dPt>
             <c:idx val="0"/>
+            <c:invertIfNegative val="0"/>
             <c:spPr>
               <a:solidFill>
                 <a:srgbClr val="264653"/>
@@ -493,6 +495,7 @@
           </c:dPt>
           <c:dPt>
             <c:idx val="1"/>
+            <c:invertIfNegative val="0"/>
             <c:spPr>
               <a:solidFill>
                 <a:srgbClr val="264653"/>
@@ -501,6 +504,7 @@
           </c:dPt>
           <c:dPt>
             <c:idx val="2"/>
+            <c:invertIfNegative val="0"/>
             <c:spPr>
               <a:solidFill>
                 <a:srgbClr val="264653"/>
@@ -509,6 +513,7 @@
           </c:dPt>
           <c:dPt>
             <c:idx val="3"/>
+            <c:invertIfNegative val="0"/>
             <c:spPr>
               <a:solidFill>
                 <a:srgbClr val="264653"/>
@@ -517,6 +522,7 @@
           </c:dPt>
           <c:dPt>
             <c:idx val="4"/>
+            <c:invertIfNegative val="0"/>
             <c:spPr>
               <a:solidFill>
                 <a:srgbClr val="264653"/>
@@ -525,6 +531,7 @@
           </c:dPt>
           <c:dPt>
             <c:idx val="5"/>
+            <c:invertIfNegative val="0"/>
             <c:spPr>
               <a:solidFill>
                 <a:srgbClr val="E76F51"/>
@@ -533,6 +540,7 @@
           </c:dPt>
           <c:dPt>
             <c:idx val="6"/>
+            <c:invertIfNegative val="0"/>
             <c:spPr>
               <a:solidFill>
                 <a:srgbClr val="E76F51"/>
@@ -634,9 +642,9 @@
         </c:scaling>
         <c:delete val="0"/>
         <c:axPos val="l"/>
-        <c:majorTickMark val="out"/>
+        <c:majorTickMark val="none"/>
         <c:minorTickMark val="none"/>
-        <c:tickLblPos val="nextTo"/>
+        <c:tickLblPos val="low"/>
         <c:spPr>
           <a:ln>
             <a:noFill/>
@@ -648,6 +656,7 @@
         <c:lblAlgn val="ctr"/>
         <c:lblOffset val="100"/>
         <c:noMultiLvlLbl val="0"/>
+        <c:tickLblSkip val="1"/>
       </c:catAx>
       <c:valAx>
         <c:axId val="-2113994440"/>
@@ -701,7 +710,7 @@
                 </a:solidFill>
                 <a:latin typeface="Calibri"/>
               </a:rPr>
-              <a:t>Influência média na previsão (|SHAP|, teste 2024)</a:t>
+              <a:t>O que explica os 95% (peso relativo, Ceará = 100)</a:t>
             </a:r>
           </a:p>
         </c:rich>
@@ -728,8 +737,282 @@
               </c:strCache>
             </c:strRef>
           </c:tx>
+          <c:invertIfNegative val="0"/>
           <c:dPt>
             <c:idx val="0"/>
+            <c:invertIfNegative val="0"/>
+            <c:spPr>
+              <a:solidFill>
+                <a:srgbClr val="E76F51"/>
+              </a:solidFill>
+            </c:spPr>
+          </c:dPt>
+          <c:dPt>
+            <c:idx val="1"/>
+            <c:invertIfNegative val="0"/>
+            <c:spPr>
+              <a:solidFill>
+                <a:srgbClr val="5B6B72"/>
+              </a:solidFill>
+            </c:spPr>
+          </c:dPt>
+          <c:dPt>
+            <c:idx val="2"/>
+            <c:invertIfNegative val="0"/>
+            <c:spPr>
+              <a:solidFill>
+                <a:srgbClr val="2A9D8F"/>
+              </a:solidFill>
+            </c:spPr>
+          </c:dPt>
+          <c:dPt>
+            <c:idx val="3"/>
+            <c:invertIfNegative val="0"/>
+            <c:spPr>
+              <a:solidFill>
+                <a:srgbClr val="2A9D8F"/>
+              </a:solidFill>
+            </c:spPr>
+          </c:dPt>
+          <c:dPt>
+            <c:idx val="4"/>
+            <c:invertIfNegative val="0"/>
+            <c:spPr>
+              <a:solidFill>
+                <a:srgbClr val="2A9D8F"/>
+              </a:solidFill>
+            </c:spPr>
+          </c:dPt>
+          <c:dPt>
+            <c:idx val="5"/>
+            <c:invertIfNegative val="0"/>
+            <c:spPr>
+              <a:solidFill>
+                <a:srgbClr val="2A9D8F"/>
+              </a:solidFill>
+            </c:spPr>
+          </c:dPt>
+          <c:dPt>
+            <c:idx val="6"/>
+            <c:invertIfNegative val="0"/>
+            <c:spPr>
+              <a:solidFill>
+                <a:srgbClr val="2A9D8F"/>
+              </a:solidFill>
+            </c:spPr>
+          </c:dPt>
+          <c:dPt>
+            <c:idx val="7"/>
+            <c:invertIfNegative val="0"/>
+            <c:spPr>
+              <a:solidFill>
+                <a:srgbClr val="2A9D8F"/>
+              </a:solidFill>
+            </c:spPr>
+          </c:dPt>
+          <c:dLbls>
+            <c:numFmt formatCode="+0;-0" sourceLinked="0"/>
+            <c:txPr>
+              <a:bodyPr/>
+              <a:lstStyle/>
+              <a:p>
+                <a:pPr>
+                  <a:defRPr sz="1200" b="1">
+                    <a:solidFill>
+                      <a:srgbClr val="1F2D33"/>
+                    </a:solidFill>
+                  </a:defRPr>
+                </a:pPr>
+              </a:p>
+            </c:txPr>
+            <c:dLblPos val="outEnd"/>
+            <c:showLegendKey val="0"/>
+            <c:showVal val="1"/>
+            <c:showCatName val="0"/>
+            <c:showSerName val="0"/>
+            <c:showPercent val="0"/>
+            <c:showBubbleSize val="0"/>
+            <c:showLeaderLines val="1"/>
+          </c:dLbls>
+          <c:cat>
+            <c:strRef>
+              <c:f>Sheet1!$A$2:$A$9</c:f>
+              <c:strCache>
+                <c:ptCount val="8"/>
+                <c:pt idx="0">
+                  <c:v>Nível socioeconômico (INSE 4,4)</c:v>
+                </c:pt>
+                <c:pt idx="1">
+                  <c:v>Demais fatores</c:v>
+                </c:pt>
+                <c:pt idx="2">
+                  <c:v>Aprovação de 100% no 2º ano</c:v>
+                </c:pt>
+                <c:pt idx="3">
+                  <c:v>Jornada de 7 horas/dia</c:v>
+                </c:pt>
+                <c:pt idx="4">
+                  <c:v>78% em tempo integral</c:v>
+                </c:pt>
+                <c:pt idx="5">
+                  <c:v>Abandono zero</c:v>
+                </c:pt>
+                <c:pt idx="6">
+                  <c:v>Distorção idade-série de 1,9%</c:v>
+                </c:pt>
+                <c:pt idx="7">
+                  <c:v>Estar no Ceará</c:v>
+                </c:pt>
+              </c:strCache>
+            </c:strRef>
+          </c:cat>
+          <c:val>
+            <c:numRef>
+              <c:f>Sheet1!$B$2:$B$9</c:f>
+              <c:numCache>
+                <c:formatCode>General</c:formatCode>
+                <c:ptCount val="8"/>
+                <c:pt idx="0">
+                  <c:v>-5</c:v>
+                </c:pt>
+                <c:pt idx="1">
+                  <c:v>28</c:v>
+                </c:pt>
+                <c:pt idx="2">
+                  <c:v>5</c:v>
+                </c:pt>
+                <c:pt idx="3">
+                  <c:v>5</c:v>
+                </c:pt>
+                <c:pt idx="4">
+                  <c:v>7</c:v>
+                </c:pt>
+                <c:pt idx="5">
+                  <c:v>22</c:v>
+                </c:pt>
+                <c:pt idx="6">
+                  <c:v>28</c:v>
+                </c:pt>
+                <c:pt idx="7">
+                  <c:v>100</c:v>
+                </c:pt>
+              </c:numCache>
+            </c:numRef>
+          </c:val>
+        </c:ser>
+        <c:gapWidth val="45"/>
+        <c:axId val="-2068027336"/>
+        <c:axId val="-2113994440"/>
+      </c:barChart>
+      <c:catAx>
+        <c:axId val="-2068027336"/>
+        <c:scaling>
+          <c:orientation val="minMax"/>
+        </c:scaling>
+        <c:delete val="0"/>
+        <c:axPos val="l"/>
+        <c:majorTickMark val="none"/>
+        <c:minorTickMark val="none"/>
+        <c:tickLblPos val="low"/>
+        <c:spPr>
+          <a:ln>
+            <a:noFill/>
+          </a:ln>
+        </c:spPr>
+        <c:crossAx val="-2113994440"/>
+        <c:crosses val="autoZero"/>
+        <c:auto val="1"/>
+        <c:lblAlgn val="ctr"/>
+        <c:lblOffset val="100"/>
+        <c:noMultiLvlLbl val="0"/>
+        <c:tickLblSkip val="1"/>
+      </c:catAx>
+      <c:valAx>
+        <c:axId val="-2113994440"/>
+        <c:scaling>
+          <c:max val="125.0"/>
+          <c:min val="-15.0"/>
+        </c:scaling>
+        <c:delete/>
+        <c:axPos val="b"/>
+        <c:majorTickMark val="out"/>
+        <c:minorTickMark val="none"/>
+        <c:tickLblPos val="nextTo"/>
+        <c:crossAx val="-2068027336"/>
+        <c:crosses val="autoZero"/>
+      </c:valAx>
+    </c:plotArea>
+    <c:dispBlanksAs val="gap"/>
+  </c:chart>
+  <c:txPr>
+    <a:bodyPr/>
+    <a:lstStyle/>
+    <a:p>
+      <a:pPr>
+        <a:defRPr sz="1200">
+          <a:solidFill>
+            <a:srgbClr val="5B6B72"/>
+          </a:solidFill>
+          <a:latin typeface="Calibri"/>
+        </a:defRPr>
+      </a:pPr>
+      <a:endParaRPr lang="en-US"/>
+    </a:p>
+  </c:txPr>
+  <c:externalData r:id="rId1">
+    <c:autoUpdate val="0"/>
+  </c:externalData>
+</c:chartSpace>
+</file>
+
+<file path=ppt/charts/chart4.xml><?xml version="1.0" encoding="utf-8"?>
+<c:chartSpace xmlns:c="http://schemas.openxmlformats.org/drawingml/2006/chart" xmlns:a="http://schemas.openxmlformats.org/drawingml/2006/main" xmlns:r="http://schemas.openxmlformats.org/officeDocument/2006/relationships">
+  <c:date1904 val="0"/>
+  <c:chart>
+    <c:title>
+      <c:tx>
+        <c:rich>
+          <a:bodyPr/>
+          <a:lstStyle/>
+          <a:p>
+            <a:r>
+              <a:rPr sz="1400" b="1">
+                <a:solidFill>
+                  <a:srgbClr val="264653"/>
+                </a:solidFill>
+                <a:latin typeface="Calibri"/>
+              </a:rPr>
+              <a:t>Influência de cada variável na previsão (estado = 100)</a:t>
+            </a:r>
+          </a:p>
+        </c:rich>
+      </c:tx>
+      <c:layout/>
+      <c:overlay val="0"/>
+    </c:title>
+    <c:autoTitleDeleted val="0"/>
+    <c:plotArea>
+      <c:barChart>
+        <c:barDir val="bar"/>
+        <c:grouping val="clustered"/>
+        <c:ser>
+          <c:idx val="0"/>
+          <c:order val="0"/>
+          <c:tx>
+            <c:strRef>
+              <c:f>Sheet1!$B$1</c:f>
+              <c:strCache>
+                <c:ptCount val="1"/>
+                <c:pt idx="0">
+                  <c:v>valor</c:v>
+                </c:pt>
+              </c:strCache>
+            </c:strRef>
+          </c:tx>
+          <c:invertIfNegative val="0"/>
+          <c:dPt>
+            <c:idx val="0"/>
+            <c:invertIfNegative val="0"/>
             <c:spPr>
               <a:solidFill>
                 <a:srgbClr val="264653"/>
@@ -738,6 +1021,7 @@
           </c:dPt>
           <c:dPt>
             <c:idx val="1"/>
+            <c:invertIfNegative val="0"/>
             <c:spPr>
               <a:solidFill>
                 <a:srgbClr val="264653"/>
@@ -746,6 +1030,7 @@
           </c:dPt>
           <c:dPt>
             <c:idx val="2"/>
+            <c:invertIfNegative val="0"/>
             <c:spPr>
               <a:solidFill>
                 <a:srgbClr val="264653"/>
@@ -754,6 +1039,7 @@
           </c:dPt>
           <c:dPt>
             <c:idx val="3"/>
+            <c:invertIfNegative val="0"/>
             <c:spPr>
               <a:solidFill>
                 <a:srgbClr val="264653"/>
@@ -762,6 +1048,7 @@
           </c:dPt>
           <c:dPt>
             <c:idx val="4"/>
+            <c:invertIfNegative val="0"/>
             <c:spPr>
               <a:solidFill>
                 <a:srgbClr val="2A9D8F"/>
@@ -770,6 +1057,7 @@
           </c:dPt>
           <c:dPt>
             <c:idx val="5"/>
+            <c:invertIfNegative val="0"/>
             <c:spPr>
               <a:solidFill>
                 <a:srgbClr val="E76F51"/>
@@ -778,6 +1066,7 @@
           </c:dPt>
           <c:dPt>
             <c:idx val="6"/>
+            <c:invertIfNegative val="0"/>
             <c:spPr>
               <a:solidFill>
                 <a:srgbClr val="E76F51"/>
@@ -786,6 +1075,7 @@
           </c:dPt>
           <c:dPt>
             <c:idx val="7"/>
+            <c:invertIfNegative val="0"/>
             <c:spPr>
               <a:solidFill>
                 <a:srgbClr val="E76F51"/>
@@ -793,7 +1083,7 @@
             </c:spPr>
           </c:dPt>
           <c:dLbls>
-            <c:numFmt formatCode="0.00" sourceLinked="0"/>
+            <c:numFmt formatCode="0" sourceLinked="0"/>
             <c:txPr>
               <a:bodyPr/>
               <a:lstStyle/>
@@ -855,28 +1145,28 @@
                 <c:formatCode>General</c:formatCode>
                 <c:ptCount val="8"/>
                 <c:pt idx="0">
-                  <c:v>0.022</c:v>
+                  <c:v>6</c:v>
                 </c:pt>
                 <c:pt idx="1">
-                  <c:v>0.032</c:v>
+                  <c:v>9</c:v>
                 </c:pt>
                 <c:pt idx="2">
-                  <c:v>0.033</c:v>
+                  <c:v>9</c:v>
                 </c:pt>
                 <c:pt idx="3">
-                  <c:v>0.044</c:v>
+                  <c:v>13</c:v>
                 </c:pt>
                 <c:pt idx="4">
-                  <c:v>0.071</c:v>
+                  <c:v>20</c:v>
                 </c:pt>
                 <c:pt idx="5">
-                  <c:v>0.112</c:v>
+                  <c:v>32</c:v>
                 </c:pt>
                 <c:pt idx="6">
-                  <c:v>0.127</c:v>
+                  <c:v>36</c:v>
                 </c:pt>
                 <c:pt idx="7">
-                  <c:v>0.348</c:v>
+                  <c:v>100</c:v>
                 </c:pt>
               </c:numCache>
             </c:numRef>
@@ -893,9 +1183,9 @@
         </c:scaling>
         <c:delete val="0"/>
         <c:axPos val="l"/>
-        <c:majorTickMark val="out"/>
+        <c:majorTickMark val="none"/>
         <c:minorTickMark val="none"/>
-        <c:tickLblPos val="nextTo"/>
+        <c:tickLblPos val="low"/>
         <c:spPr>
           <a:ln>
             <a:noFill/>
@@ -907,11 +1197,12 @@
         <c:lblAlgn val="ctr"/>
         <c:lblOffset val="100"/>
         <c:noMultiLvlLbl val="0"/>
+        <c:tickLblSkip val="1"/>
       </c:catAx>
       <c:valAx>
         <c:axId val="-2113994440"/>
         <c:scaling>
-          <c:max val="0.42"/>
+          <c:max val="120.0"/>
         </c:scaling>
         <c:delete/>
         <c:axPos val="b"/>
@@ -945,7 +1236,7 @@
 </c:chartSpace>
 </file>
 
-<file path=ppt/charts/chart4.xml><?xml version="1.0" encoding="utf-8"?>
+<file path=ppt/charts/chart5.xml><?xml version="1.0" encoding="utf-8"?>
 <c:chartSpace xmlns:c="http://schemas.openxmlformats.org/drawingml/2006/chart" xmlns:a="http://schemas.openxmlformats.org/drawingml/2006/main" xmlns:r="http://schemas.openxmlformats.org/officeDocument/2006/relationships">
   <c:date1904 val="0"/>
   <c:chart>
@@ -962,7 +1253,7 @@
                 </a:solidFill>
                 <a:latin typeface="Calibri"/>
               </a:rPr>
-              <a:t>% de alfabetizados por grupo de contexto (2024)</a:t>
+              <a:t>Efeito do estado além do contexto (Ceará = 100)</a:t>
             </a:r>
           </a:p>
         </c:rich>
@@ -989,8 +1280,10 @@
               </c:strCache>
             </c:strRef>
           </c:tx>
+          <c:invertIfNegative val="0"/>
           <c:dPt>
             <c:idx val="0"/>
+            <c:invertIfNegative val="0"/>
             <c:spPr>
               <a:solidFill>
                 <a:srgbClr val="E76F51"/>
@@ -999,6 +1292,549 @@
           </c:dPt>
           <c:dPt>
             <c:idx val="1"/>
+            <c:invertIfNegative val="0"/>
+            <c:spPr>
+              <a:solidFill>
+                <a:srgbClr val="E76F51"/>
+              </a:solidFill>
+            </c:spPr>
+          </c:dPt>
+          <c:dPt>
+            <c:idx val="2"/>
+            <c:invertIfNegative val="0"/>
+            <c:spPr>
+              <a:solidFill>
+                <a:srgbClr val="E76F51"/>
+              </a:solidFill>
+            </c:spPr>
+          </c:dPt>
+          <c:dPt>
+            <c:idx val="3"/>
+            <c:invertIfNegative val="0"/>
+            <c:spPr>
+              <a:solidFill>
+                <a:srgbClr val="E76F51"/>
+              </a:solidFill>
+            </c:spPr>
+          </c:dPt>
+          <c:dPt>
+            <c:idx val="4"/>
+            <c:invertIfNegative val="0"/>
+            <c:spPr>
+              <a:solidFill>
+                <a:srgbClr val="E76F51"/>
+              </a:solidFill>
+            </c:spPr>
+          </c:dPt>
+          <c:dPt>
+            <c:idx val="5"/>
+            <c:invertIfNegative val="0"/>
+            <c:spPr>
+              <a:solidFill>
+                <a:srgbClr val="E76F51"/>
+              </a:solidFill>
+            </c:spPr>
+          </c:dPt>
+          <c:dPt>
+            <c:idx val="6"/>
+            <c:invertIfNegative val="0"/>
+            <c:spPr>
+              <a:solidFill>
+                <a:srgbClr val="E76F51"/>
+              </a:solidFill>
+            </c:spPr>
+          </c:dPt>
+          <c:dPt>
+            <c:idx val="7"/>
+            <c:invertIfNegative val="0"/>
+            <c:spPr>
+              <a:solidFill>
+                <a:srgbClr val="E76F51"/>
+              </a:solidFill>
+            </c:spPr>
+          </c:dPt>
+          <c:dPt>
+            <c:idx val="8"/>
+            <c:invertIfNegative val="0"/>
+            <c:spPr>
+              <a:solidFill>
+                <a:srgbClr val="E76F51"/>
+              </a:solidFill>
+            </c:spPr>
+          </c:dPt>
+          <c:dPt>
+            <c:idx val="9"/>
+            <c:invertIfNegative val="0"/>
+            <c:spPr>
+              <a:solidFill>
+                <a:srgbClr val="E76F51"/>
+              </a:solidFill>
+            </c:spPr>
+          </c:dPt>
+          <c:dPt>
+            <c:idx val="10"/>
+            <c:invertIfNegative val="0"/>
+            <c:spPr>
+              <a:solidFill>
+                <a:srgbClr val="E76F51"/>
+              </a:solidFill>
+            </c:spPr>
+          </c:dPt>
+          <c:dPt>
+            <c:idx val="11"/>
+            <c:invertIfNegative val="0"/>
+            <c:spPr>
+              <a:solidFill>
+                <a:srgbClr val="E76F51"/>
+              </a:solidFill>
+            </c:spPr>
+          </c:dPt>
+          <c:dPt>
+            <c:idx val="12"/>
+            <c:invertIfNegative val="0"/>
+            <c:spPr>
+              <a:solidFill>
+                <a:srgbClr val="E76F51"/>
+              </a:solidFill>
+            </c:spPr>
+          </c:dPt>
+          <c:dPt>
+            <c:idx val="13"/>
+            <c:invertIfNegative val="0"/>
+            <c:spPr>
+              <a:solidFill>
+                <a:srgbClr val="E76F51"/>
+              </a:solidFill>
+            </c:spPr>
+          </c:dPt>
+          <c:dPt>
+            <c:idx val="14"/>
+            <c:invertIfNegative val="0"/>
+            <c:spPr>
+              <a:solidFill>
+                <a:srgbClr val="E76F51"/>
+              </a:solidFill>
+            </c:spPr>
+          </c:dPt>
+          <c:dPt>
+            <c:idx val="15"/>
+            <c:invertIfNegative val="0"/>
+            <c:spPr>
+              <a:solidFill>
+                <a:srgbClr val="E76F51"/>
+              </a:solidFill>
+            </c:spPr>
+          </c:dPt>
+          <c:dPt>
+            <c:idx val="16"/>
+            <c:invertIfNegative val="0"/>
+            <c:spPr>
+              <a:solidFill>
+                <a:srgbClr val="E76F51"/>
+              </a:solidFill>
+            </c:spPr>
+          </c:dPt>
+          <c:dPt>
+            <c:idx val="17"/>
+            <c:invertIfNegative val="0"/>
+            <c:spPr>
+              <a:solidFill>
+                <a:srgbClr val="E76F51"/>
+              </a:solidFill>
+            </c:spPr>
+          </c:dPt>
+          <c:dPt>
+            <c:idx val="18"/>
+            <c:invertIfNegative val="0"/>
+            <c:spPr>
+              <a:solidFill>
+                <a:srgbClr val="E76F51"/>
+              </a:solidFill>
+            </c:spPr>
+          </c:dPt>
+          <c:dPt>
+            <c:idx val="19"/>
+            <c:invertIfNegative val="0"/>
+            <c:spPr>
+              <a:solidFill>
+                <a:srgbClr val="2A9D8F"/>
+              </a:solidFill>
+            </c:spPr>
+          </c:dPt>
+          <c:dPt>
+            <c:idx val="20"/>
+            <c:invertIfNegative val="0"/>
+            <c:spPr>
+              <a:solidFill>
+                <a:srgbClr val="2A9D8F"/>
+              </a:solidFill>
+            </c:spPr>
+          </c:dPt>
+          <c:dPt>
+            <c:idx val="21"/>
+            <c:invertIfNegative val="0"/>
+            <c:spPr>
+              <a:solidFill>
+                <a:srgbClr val="2A9D8F"/>
+              </a:solidFill>
+            </c:spPr>
+          </c:dPt>
+          <c:dPt>
+            <c:idx val="22"/>
+            <c:invertIfNegative val="0"/>
+            <c:spPr>
+              <a:solidFill>
+                <a:srgbClr val="2A9D8F"/>
+              </a:solidFill>
+            </c:spPr>
+          </c:dPt>
+          <c:dPt>
+            <c:idx val="23"/>
+            <c:invertIfNegative val="0"/>
+            <c:spPr>
+              <a:solidFill>
+                <a:srgbClr val="2A9D8F"/>
+              </a:solidFill>
+            </c:spPr>
+          </c:dPt>
+          <c:dPt>
+            <c:idx val="24"/>
+            <c:invertIfNegative val="0"/>
+            <c:spPr>
+              <a:solidFill>
+                <a:srgbClr val="2A9D8F"/>
+              </a:solidFill>
+            </c:spPr>
+          </c:dPt>
+          <c:dPt>
+            <c:idx val="25"/>
+            <c:invertIfNegative val="0"/>
+            <c:spPr>
+              <a:solidFill>
+                <a:srgbClr val="2A9D8F"/>
+              </a:solidFill>
+            </c:spPr>
+          </c:dPt>
+          <c:dLbls>
+            <c:numFmt formatCode="+0;-0" sourceLinked="0"/>
+            <c:txPr>
+              <a:bodyPr/>
+              <a:lstStyle/>
+              <a:p>
+                <a:pPr>
+                  <a:defRPr sz="1000" b="1">
+                    <a:solidFill>
+                      <a:srgbClr val="1F2D33"/>
+                    </a:solidFill>
+                  </a:defRPr>
+                </a:pPr>
+              </a:p>
+            </c:txPr>
+            <c:dLblPos val="outEnd"/>
+            <c:showLegendKey val="0"/>
+            <c:showVal val="1"/>
+            <c:showCatName val="0"/>
+            <c:showSerName val="0"/>
+            <c:showPercent val="0"/>
+            <c:showBubbleSize val="0"/>
+            <c:showLeaderLines val="1"/>
+          </c:dLbls>
+          <c:cat>
+            <c:strRef>
+              <c:f>Sheet1!$A$2:$A$27</c:f>
+              <c:strCache>
+                <c:ptCount val="26"/>
+                <c:pt idx="0">
+                  <c:v>SE</c:v>
+                </c:pt>
+                <c:pt idx="1">
+                  <c:v>RN</c:v>
+                </c:pt>
+                <c:pt idx="2">
+                  <c:v>TO</c:v>
+                </c:pt>
+                <c:pt idx="3">
+                  <c:v>BA</c:v>
+                </c:pt>
+                <c:pt idx="4">
+                  <c:v>SC</c:v>
+                </c:pt>
+                <c:pt idx="5">
+                  <c:v>AL</c:v>
+                </c:pt>
+                <c:pt idx="6">
+                  <c:v>MT</c:v>
+                </c:pt>
+                <c:pt idx="7">
+                  <c:v>MS</c:v>
+                </c:pt>
+                <c:pt idx="8">
+                  <c:v>MG</c:v>
+                </c:pt>
+                <c:pt idx="9">
+                  <c:v>SP</c:v>
+                </c:pt>
+                <c:pt idx="10">
+                  <c:v>DF</c:v>
+                </c:pt>
+                <c:pt idx="11">
+                  <c:v>AP</c:v>
+                </c:pt>
+                <c:pt idx="12">
+                  <c:v>RS</c:v>
+                </c:pt>
+                <c:pt idx="13">
+                  <c:v>PB</c:v>
+                </c:pt>
+                <c:pt idx="14">
+                  <c:v>RJ</c:v>
+                </c:pt>
+                <c:pt idx="15">
+                  <c:v>PI</c:v>
+                </c:pt>
+                <c:pt idx="16">
+                  <c:v>AM</c:v>
+                </c:pt>
+                <c:pt idx="17">
+                  <c:v>AC</c:v>
+                </c:pt>
+                <c:pt idx="18">
+                  <c:v>PA</c:v>
+                </c:pt>
+                <c:pt idx="19">
+                  <c:v>RO</c:v>
+                </c:pt>
+                <c:pt idx="20">
+                  <c:v>MA</c:v>
+                </c:pt>
+                <c:pt idx="21">
+                  <c:v>PE</c:v>
+                </c:pt>
+                <c:pt idx="22">
+                  <c:v>PR</c:v>
+                </c:pt>
+                <c:pt idx="23">
+                  <c:v>ES</c:v>
+                </c:pt>
+                <c:pt idx="24">
+                  <c:v>GO</c:v>
+                </c:pt>
+                <c:pt idx="25">
+                  <c:v>CE</c:v>
+                </c:pt>
+              </c:strCache>
+            </c:strRef>
+          </c:cat>
+          <c:val>
+            <c:numRef>
+              <c:f>Sheet1!$B$2:$B$27</c:f>
+              <c:numCache>
+                <c:formatCode>General</c:formatCode>
+                <c:ptCount val="26"/>
+                <c:pt idx="0">
+                  <c:v>-65</c:v>
+                </c:pt>
+                <c:pt idx="1">
+                  <c:v>-48</c:v>
+                </c:pt>
+                <c:pt idx="2">
+                  <c:v>-46</c:v>
+                </c:pt>
+                <c:pt idx="3">
+                  <c:v>-38</c:v>
+                </c:pt>
+                <c:pt idx="4">
+                  <c:v>-23</c:v>
+                </c:pt>
+                <c:pt idx="5">
+                  <c:v>-22</c:v>
+                </c:pt>
+                <c:pt idx="6">
+                  <c:v>-18</c:v>
+                </c:pt>
+                <c:pt idx="7">
+                  <c:v>-17</c:v>
+                </c:pt>
+                <c:pt idx="8">
+                  <c:v>-12</c:v>
+                </c:pt>
+                <c:pt idx="9">
+                  <c:v>-8</c:v>
+                </c:pt>
+                <c:pt idx="10">
+                  <c:v>-7</c:v>
+                </c:pt>
+                <c:pt idx="11">
+                  <c:v>-7</c:v>
+                </c:pt>
+                <c:pt idx="12">
+                  <c:v>-6</c:v>
+                </c:pt>
+                <c:pt idx="13">
+                  <c:v>-6</c:v>
+                </c:pt>
+                <c:pt idx="14">
+                  <c:v>-5</c:v>
+                </c:pt>
+                <c:pt idx="15">
+                  <c:v>-4</c:v>
+                </c:pt>
+                <c:pt idx="16">
+                  <c:v>-3</c:v>
+                </c:pt>
+                <c:pt idx="17">
+                  <c:v>-3</c:v>
+                </c:pt>
+                <c:pt idx="18">
+                  <c:v>-3</c:v>
+                </c:pt>
+                <c:pt idx="19">
+                  <c:v>8</c:v>
+                </c:pt>
+                <c:pt idx="20">
+                  <c:v>10</c:v>
+                </c:pt>
+                <c:pt idx="21">
+                  <c:v>10</c:v>
+                </c:pt>
+                <c:pt idx="22">
+                  <c:v>16</c:v>
+                </c:pt>
+                <c:pt idx="23">
+                  <c:v>20</c:v>
+                </c:pt>
+                <c:pt idx="24">
+                  <c:v>21</c:v>
+                </c:pt>
+                <c:pt idx="25">
+                  <c:v>100</c:v>
+                </c:pt>
+              </c:numCache>
+            </c:numRef>
+          </c:val>
+        </c:ser>
+        <c:gapWidth val="45"/>
+        <c:axId val="-2068027336"/>
+        <c:axId val="-2113994440"/>
+      </c:barChart>
+      <c:catAx>
+        <c:axId val="-2068027336"/>
+        <c:scaling>
+          <c:orientation val="minMax"/>
+        </c:scaling>
+        <c:delete val="0"/>
+        <c:axPos val="l"/>
+        <c:majorTickMark val="none"/>
+        <c:minorTickMark val="none"/>
+        <c:tickLblPos val="low"/>
+        <c:spPr>
+          <a:ln>
+            <a:noFill/>
+          </a:ln>
+        </c:spPr>
+        <c:crossAx val="-2113994440"/>
+        <c:crosses val="autoZero"/>
+        <c:auto val="1"/>
+        <c:lblAlgn val="ctr"/>
+        <c:lblOffset val="100"/>
+        <c:noMultiLvlLbl val="0"/>
+        <c:tickLblSkip val="1"/>
+      </c:catAx>
+      <c:valAx>
+        <c:axId val="-2113994440"/>
+        <c:scaling>
+          <c:max val="120.0"/>
+          <c:min val="-80.0"/>
+        </c:scaling>
+        <c:delete/>
+        <c:axPos val="b"/>
+        <c:majorTickMark val="out"/>
+        <c:minorTickMark val="none"/>
+        <c:tickLblPos val="nextTo"/>
+        <c:crossAx val="-2068027336"/>
+        <c:crosses val="autoZero"/>
+      </c:valAx>
+    </c:plotArea>
+    <c:dispBlanksAs val="gap"/>
+  </c:chart>
+  <c:txPr>
+    <a:bodyPr/>
+    <a:lstStyle/>
+    <a:p>
+      <a:pPr>
+        <a:defRPr sz="1000">
+          <a:solidFill>
+            <a:srgbClr val="5B6B72"/>
+          </a:solidFill>
+          <a:latin typeface="Calibri"/>
+        </a:defRPr>
+      </a:pPr>
+      <a:endParaRPr lang="en-US"/>
+    </a:p>
+  </c:txPr>
+  <c:externalData r:id="rId1">
+    <c:autoUpdate val="0"/>
+  </c:externalData>
+</c:chartSpace>
+</file>
+
+<file path=ppt/charts/chart6.xml><?xml version="1.0" encoding="utf-8"?>
+<c:chartSpace xmlns:c="http://schemas.openxmlformats.org/drawingml/2006/chart" xmlns:a="http://schemas.openxmlformats.org/drawingml/2006/main" xmlns:r="http://schemas.openxmlformats.org/officeDocument/2006/relationships">
+  <c:date1904 val="0"/>
+  <c:chart>
+    <c:title>
+      <c:tx>
+        <c:rich>
+          <a:bodyPr/>
+          <a:lstStyle/>
+          <a:p>
+            <a:r>
+              <a:rPr sz="1400" b="1">
+                <a:solidFill>
+                  <a:srgbClr val="264653"/>
+                </a:solidFill>
+                <a:latin typeface="Calibri"/>
+              </a:rPr>
+              <a:t>% de alfabetizados por grupo de contexto (2024)</a:t>
+            </a:r>
+          </a:p>
+        </c:rich>
+      </c:tx>
+      <c:layout/>
+      <c:overlay val="0"/>
+    </c:title>
+    <c:autoTitleDeleted val="0"/>
+    <c:plotArea>
+      <c:barChart>
+        <c:barDir val="bar"/>
+        <c:grouping val="clustered"/>
+        <c:ser>
+          <c:idx val="0"/>
+          <c:order val="0"/>
+          <c:tx>
+            <c:strRef>
+              <c:f>Sheet1!$B$1</c:f>
+              <c:strCache>
+                <c:ptCount val="1"/>
+                <c:pt idx="0">
+                  <c:v>valor</c:v>
+                </c:pt>
+              </c:strCache>
+            </c:strRef>
+          </c:tx>
+          <c:invertIfNegative val="0"/>
+          <c:dPt>
+            <c:idx val="0"/>
+            <c:invertIfNegative val="0"/>
+            <c:spPr>
+              <a:solidFill>
+                <a:srgbClr val="E76F51"/>
+              </a:solidFill>
+            </c:spPr>
+          </c:dPt>
+          <c:dPt>
+            <c:idx val="1"/>
+            <c:invertIfNegative val="0"/>
             <c:spPr>
               <a:solidFill>
                 <a:srgbClr val="F4A261"/>
@@ -1007,6 +1843,7 @@
           </c:dPt>
           <c:dPt>
             <c:idx val="2"/>
+            <c:invertIfNegative val="0"/>
             <c:spPr>
               <a:solidFill>
                 <a:srgbClr val="E9C46A"/>
@@ -1015,6 +1852,7 @@
           </c:dPt>
           <c:dPt>
             <c:idx val="3"/>
+            <c:invertIfNegative val="0"/>
             <c:spPr>
               <a:solidFill>
                 <a:srgbClr val="2A9D8F"/>
@@ -1023,6 +1861,7 @@
           </c:dPt>
           <c:dPt>
             <c:idx val="4"/>
+            <c:invertIfNegative val="0"/>
             <c:spPr>
               <a:solidFill>
                 <a:srgbClr val="264653"/>
@@ -1112,9 +1951,9 @@
         </c:scaling>
         <c:delete val="0"/>
         <c:axPos val="l"/>
-        <c:majorTickMark val="out"/>
+        <c:majorTickMark val="none"/>
         <c:minorTickMark val="none"/>
-        <c:tickLblPos val="nextTo"/>
+        <c:tickLblPos val="low"/>
         <c:spPr>
           <a:ln>
             <a:noFill/>
@@ -1126,6 +1965,7 @@
         <c:lblAlgn val="ctr"/>
         <c:lblOffset val="100"/>
         <c:noMultiLvlLbl val="0"/>
+        <c:tickLblSkip val="1"/>
       </c:catAx>
       <c:valAx>
         <c:axId val="-2113994440"/>
@@ -1149,6 +1989,503 @@
     <a:p>
       <a:pPr>
         <a:defRPr sz="1300">
+          <a:solidFill>
+            <a:srgbClr val="5B6B72"/>
+          </a:solidFill>
+          <a:latin typeface="Calibri"/>
+        </a:defRPr>
+      </a:pPr>
+      <a:endParaRPr lang="en-US"/>
+    </a:p>
+  </c:txPr>
+  <c:externalData r:id="rId1">
+    <c:autoUpdate val="0"/>
+  </c:externalData>
+</c:chartSpace>
+</file>
+
+<file path=ppt/charts/chart7.xml><?xml version="1.0" encoding="utf-8"?>
+<c:chartSpace xmlns:c="http://schemas.openxmlformats.org/drawingml/2006/chart" xmlns:a="http://schemas.openxmlformats.org/drawingml/2006/main" xmlns:r="http://schemas.openxmlformats.org/officeDocument/2006/relationships">
+  <c:date1904 val="0"/>
+  <c:chart>
+    <c:title>
+      <c:tx>
+        <c:rich>
+          <a:bodyPr/>
+          <a:lstStyle/>
+          <a:p>
+            <a:r>
+              <a:rPr sz="1400" b="1">
+                <a:solidFill>
+                  <a:srgbClr val="264653"/>
+                </a:solidFill>
+                <a:latin typeface="Calibri"/>
+              </a:rPr>
+              <a:t>Variação 2023-2024 acima ou abaixo do Brasil (pontos)</a:t>
+            </a:r>
+          </a:p>
+        </c:rich>
+      </c:tx>
+      <c:layout/>
+      <c:overlay val="0"/>
+    </c:title>
+    <c:autoTitleDeleted val="0"/>
+    <c:plotArea>
+      <c:barChart>
+        <c:barDir val="bar"/>
+        <c:grouping val="clustered"/>
+        <c:ser>
+          <c:idx val="0"/>
+          <c:order val="0"/>
+          <c:tx>
+            <c:strRef>
+              <c:f>Sheet1!$B$1</c:f>
+              <c:strCache>
+                <c:ptCount val="1"/>
+                <c:pt idx="0">
+                  <c:v>valor</c:v>
+                </c:pt>
+              </c:strCache>
+            </c:strRef>
+          </c:tx>
+          <c:invertIfNegative val="0"/>
+          <c:dPt>
+            <c:idx val="0"/>
+            <c:invertIfNegative val="0"/>
+            <c:spPr>
+              <a:solidFill>
+                <a:srgbClr val="E76F51"/>
+              </a:solidFill>
+            </c:spPr>
+          </c:dPt>
+          <c:dPt>
+            <c:idx val="1"/>
+            <c:invertIfNegative val="0"/>
+            <c:spPr>
+              <a:solidFill>
+                <a:srgbClr val="264653"/>
+              </a:solidFill>
+            </c:spPr>
+          </c:dPt>
+          <c:dPt>
+            <c:idx val="2"/>
+            <c:invertIfNegative val="0"/>
+            <c:spPr>
+              <a:solidFill>
+                <a:srgbClr val="264653"/>
+              </a:solidFill>
+            </c:spPr>
+          </c:dPt>
+          <c:dPt>
+            <c:idx val="3"/>
+            <c:invertIfNegative val="0"/>
+            <c:spPr>
+              <a:solidFill>
+                <a:srgbClr val="264653"/>
+              </a:solidFill>
+            </c:spPr>
+          </c:dPt>
+          <c:dPt>
+            <c:idx val="4"/>
+            <c:invertIfNegative val="0"/>
+            <c:spPr>
+              <a:solidFill>
+                <a:srgbClr val="264653"/>
+              </a:solidFill>
+            </c:spPr>
+          </c:dPt>
+          <c:dPt>
+            <c:idx val="5"/>
+            <c:invertIfNegative val="0"/>
+            <c:spPr>
+              <a:solidFill>
+                <a:srgbClr val="264653"/>
+              </a:solidFill>
+            </c:spPr>
+          </c:dPt>
+          <c:dPt>
+            <c:idx val="6"/>
+            <c:invertIfNegative val="0"/>
+            <c:spPr>
+              <a:solidFill>
+                <a:srgbClr val="264653"/>
+              </a:solidFill>
+            </c:spPr>
+          </c:dPt>
+          <c:dPt>
+            <c:idx val="7"/>
+            <c:invertIfNegative val="0"/>
+            <c:spPr>
+              <a:solidFill>
+                <a:srgbClr val="264653"/>
+              </a:solidFill>
+            </c:spPr>
+          </c:dPt>
+          <c:dPt>
+            <c:idx val="8"/>
+            <c:invertIfNegative val="0"/>
+            <c:spPr>
+              <a:solidFill>
+                <a:srgbClr val="264653"/>
+              </a:solidFill>
+            </c:spPr>
+          </c:dPt>
+          <c:dPt>
+            <c:idx val="9"/>
+            <c:invertIfNegative val="0"/>
+            <c:spPr>
+              <a:solidFill>
+                <a:srgbClr val="264653"/>
+              </a:solidFill>
+            </c:spPr>
+          </c:dPt>
+          <c:dPt>
+            <c:idx val="10"/>
+            <c:invertIfNegative val="0"/>
+            <c:spPr>
+              <a:solidFill>
+                <a:srgbClr val="264653"/>
+              </a:solidFill>
+            </c:spPr>
+          </c:dPt>
+          <c:dPt>
+            <c:idx val="11"/>
+            <c:invertIfNegative val="0"/>
+            <c:spPr>
+              <a:solidFill>
+                <a:srgbClr val="264653"/>
+              </a:solidFill>
+            </c:spPr>
+          </c:dPt>
+          <c:dPt>
+            <c:idx val="12"/>
+            <c:invertIfNegative val="0"/>
+            <c:spPr>
+              <a:solidFill>
+                <a:srgbClr val="264653"/>
+              </a:solidFill>
+            </c:spPr>
+          </c:dPt>
+          <c:dPt>
+            <c:idx val="13"/>
+            <c:invertIfNegative val="0"/>
+            <c:spPr>
+              <a:solidFill>
+                <a:srgbClr val="264653"/>
+              </a:solidFill>
+            </c:spPr>
+          </c:dPt>
+          <c:dPt>
+            <c:idx val="14"/>
+            <c:invertIfNegative val="0"/>
+            <c:spPr>
+              <a:solidFill>
+                <a:srgbClr val="264653"/>
+              </a:solidFill>
+            </c:spPr>
+          </c:dPt>
+          <c:dPt>
+            <c:idx val="15"/>
+            <c:invertIfNegative val="0"/>
+            <c:spPr>
+              <a:solidFill>
+                <a:srgbClr val="264653"/>
+              </a:solidFill>
+            </c:spPr>
+          </c:dPt>
+          <c:dPt>
+            <c:idx val="16"/>
+            <c:invertIfNegative val="0"/>
+            <c:spPr>
+              <a:solidFill>
+                <a:srgbClr val="264653"/>
+              </a:solidFill>
+            </c:spPr>
+          </c:dPt>
+          <c:dPt>
+            <c:idx val="17"/>
+            <c:invertIfNegative val="0"/>
+            <c:spPr>
+              <a:solidFill>
+                <a:srgbClr val="264653"/>
+              </a:solidFill>
+            </c:spPr>
+          </c:dPt>
+          <c:dPt>
+            <c:idx val="18"/>
+            <c:invertIfNegative val="0"/>
+            <c:spPr>
+              <a:solidFill>
+                <a:srgbClr val="264653"/>
+              </a:solidFill>
+            </c:spPr>
+          </c:dPt>
+          <c:dPt>
+            <c:idx val="19"/>
+            <c:invertIfNegative val="0"/>
+            <c:spPr>
+              <a:solidFill>
+                <a:srgbClr val="264653"/>
+              </a:solidFill>
+            </c:spPr>
+          </c:dPt>
+          <c:dPt>
+            <c:idx val="20"/>
+            <c:invertIfNegative val="0"/>
+            <c:spPr>
+              <a:solidFill>
+                <a:srgbClr val="264653"/>
+              </a:solidFill>
+            </c:spPr>
+          </c:dPt>
+          <c:dPt>
+            <c:idx val="21"/>
+            <c:invertIfNegative val="0"/>
+            <c:spPr>
+              <a:solidFill>
+                <a:srgbClr val="264653"/>
+              </a:solidFill>
+            </c:spPr>
+          </c:dPt>
+          <c:dPt>
+            <c:idx val="22"/>
+            <c:invertIfNegative val="0"/>
+            <c:spPr>
+              <a:solidFill>
+                <a:srgbClr val="E76F51"/>
+              </a:solidFill>
+            </c:spPr>
+          </c:dPt>
+          <c:dLbls>
+            <c:numFmt formatCode="+0;-0;0" sourceLinked="0"/>
+            <c:txPr>
+              <a:bodyPr/>
+              <a:lstStyle/>
+              <a:p>
+                <a:pPr>
+                  <a:defRPr sz="1000" b="1">
+                    <a:solidFill>
+                      <a:srgbClr val="1F2D33"/>
+                    </a:solidFill>
+                  </a:defRPr>
+                </a:pPr>
+              </a:p>
+            </c:txPr>
+            <c:dLblPos val="outEnd"/>
+            <c:showLegendKey val="0"/>
+            <c:showVal val="1"/>
+            <c:showCatName val="0"/>
+            <c:showSerName val="0"/>
+            <c:showPercent val="0"/>
+            <c:showBubbleSize val="0"/>
+            <c:showLeaderLines val="1"/>
+          </c:dLbls>
+          <c:cat>
+            <c:strRef>
+              <c:f>Sheet1!$A$2:$A$24</c:f>
+              <c:strCache>
+                <c:ptCount val="23"/>
+                <c:pt idx="0">
+                  <c:v>RS</c:v>
+                </c:pt>
+                <c:pt idx="1">
+                  <c:v>RO</c:v>
+                </c:pt>
+                <c:pt idx="2">
+                  <c:v>PR</c:v>
+                </c:pt>
+                <c:pt idx="3">
+                  <c:v>AM</c:v>
+                </c:pt>
+                <c:pt idx="4">
+                  <c:v>BA</c:v>
+                </c:pt>
+                <c:pt idx="5">
+                  <c:v>PA</c:v>
+                </c:pt>
+                <c:pt idx="6">
+                  <c:v>CE</c:v>
+                </c:pt>
+                <c:pt idx="7">
+                  <c:v>SC</c:v>
+                </c:pt>
+                <c:pt idx="8">
+                  <c:v>PE</c:v>
+                </c:pt>
+                <c:pt idx="9">
+                  <c:v>RN</c:v>
+                </c:pt>
+                <c:pt idx="10">
+                  <c:v>MA</c:v>
+                </c:pt>
+                <c:pt idx="11">
+                  <c:v>RJ</c:v>
+                </c:pt>
+                <c:pt idx="12">
+                  <c:v>ES</c:v>
+                </c:pt>
+                <c:pt idx="13">
+                  <c:v>PB</c:v>
+                </c:pt>
+                <c:pt idx="14">
+                  <c:v>AL</c:v>
+                </c:pt>
+                <c:pt idx="15">
+                  <c:v>MT</c:v>
+                </c:pt>
+                <c:pt idx="16">
+                  <c:v>GO</c:v>
+                </c:pt>
+                <c:pt idx="17">
+                  <c:v>TO</c:v>
+                </c:pt>
+                <c:pt idx="18">
+                  <c:v>AP</c:v>
+                </c:pt>
+                <c:pt idx="19">
+                  <c:v>PI</c:v>
+                </c:pt>
+                <c:pt idx="20">
+                  <c:v>SE</c:v>
+                </c:pt>
+                <c:pt idx="21">
+                  <c:v>MS</c:v>
+                </c:pt>
+                <c:pt idx="22">
+                  <c:v>MG</c:v>
+                </c:pt>
+              </c:strCache>
+            </c:strRef>
+          </c:cat>
+          <c:val>
+            <c:numRef>
+              <c:f>Sheet1!$B$2:$B$24</c:f>
+              <c:numCache>
+                <c:formatCode>General</c:formatCode>
+                <c:ptCount val="23"/>
+                <c:pt idx="0">
+                  <c:v>-22</c:v>
+                </c:pt>
+                <c:pt idx="1">
+                  <c:v>-5</c:v>
+                </c:pt>
+                <c:pt idx="2">
+                  <c:v>-5</c:v>
+                </c:pt>
+                <c:pt idx="3">
+                  <c:v>-5</c:v>
+                </c:pt>
+                <c:pt idx="4">
+                  <c:v>-3</c:v>
+                </c:pt>
+                <c:pt idx="5">
+                  <c:v>-2</c:v>
+                </c:pt>
+                <c:pt idx="6">
+                  <c:v>-2</c:v>
+                </c:pt>
+                <c:pt idx="7">
+                  <c:v>0</c:v>
+                </c:pt>
+                <c:pt idx="8">
+                  <c:v>0</c:v>
+                </c:pt>
+                <c:pt idx="9">
+                  <c:v>0</c:v>
+                </c:pt>
+                <c:pt idx="10">
+                  <c:v>1</c:v>
+                </c:pt>
+                <c:pt idx="11">
+                  <c:v>1</c:v>
+                </c:pt>
+                <c:pt idx="12">
+                  <c:v>1</c:v>
+                </c:pt>
+                <c:pt idx="13">
+                  <c:v>3</c:v>
+                </c:pt>
+                <c:pt idx="14">
+                  <c:v>3</c:v>
+                </c:pt>
+                <c:pt idx="15">
+                  <c:v>3</c:v>
+                </c:pt>
+                <c:pt idx="16">
+                  <c:v>4</c:v>
+                </c:pt>
+                <c:pt idx="17">
+                  <c:v>4</c:v>
+                </c:pt>
+                <c:pt idx="18">
+                  <c:v>5</c:v>
+                </c:pt>
+                <c:pt idx="19">
+                  <c:v>5</c:v>
+                </c:pt>
+                <c:pt idx="20">
+                  <c:v>5</c:v>
+                </c:pt>
+                <c:pt idx="21">
+                  <c:v>6</c:v>
+                </c:pt>
+                <c:pt idx="22">
+                  <c:v>10</c:v>
+                </c:pt>
+              </c:numCache>
+            </c:numRef>
+          </c:val>
+        </c:ser>
+        <c:gapWidth val="45"/>
+        <c:axId val="-2068027336"/>
+        <c:axId val="-2113994440"/>
+      </c:barChart>
+      <c:catAx>
+        <c:axId val="-2068027336"/>
+        <c:scaling>
+          <c:orientation val="minMax"/>
+        </c:scaling>
+        <c:delete val="0"/>
+        <c:axPos val="l"/>
+        <c:majorTickMark val="none"/>
+        <c:minorTickMark val="none"/>
+        <c:tickLblPos val="low"/>
+        <c:spPr>
+          <a:ln>
+            <a:noFill/>
+          </a:ln>
+        </c:spPr>
+        <c:crossAx val="-2113994440"/>
+        <c:crosses val="autoZero"/>
+        <c:auto val="1"/>
+        <c:lblAlgn val="ctr"/>
+        <c:lblOffset val="100"/>
+        <c:noMultiLvlLbl val="0"/>
+        <c:tickLblSkip val="1"/>
+      </c:catAx>
+      <c:valAx>
+        <c:axId val="-2113994440"/>
+        <c:scaling>
+          <c:max val="15.0"/>
+          <c:min val="-27.0"/>
+        </c:scaling>
+        <c:delete/>
+        <c:axPos val="b"/>
+        <c:majorTickMark val="out"/>
+        <c:minorTickMark val="none"/>
+        <c:tickLblPos val="nextTo"/>
+        <c:crossAx val="-2068027336"/>
+        <c:crosses val="autoZero"/>
+      </c:valAx>
+    </c:plotArea>
+    <c:dispBlanksAs val="gap"/>
+  </c:chart>
+  <c:txPr>
+    <a:bodyPr/>
+    <a:lstStyle/>
+    <a:p>
+      <a:pPr>
+        <a:defRPr sz="1000">
           <a:solidFill>
             <a:srgbClr val="5B6B72"/>
           </a:solidFill>
@@ -1839,7 +3176,7 @@
           <a:lstStyle/>
           <a:p>
             <a:r>
-              <a:t>Quinta pergunta: o modelo aprende como as redes se saíram de um ano para o outro e projeta a chance de bater a meta de 2025. Cerca de 1.400 redes têm menos de 40%. A queda do Rio Grande do Sul nas enchentes não é projetada como tendência.</a:t>
+              <a:t>Quinta pergunta: o modelo aprende como as redes se saíram de um ano para o outro e projeta a chance de bater a meta de 2025. Cerca de 1.400 redes têm menos de 40%. A queda do Rio Grande do Sul nas enchentes, fora da curva, não vira tendência.</a:t>
             </a:r>
           </a:p>
         </p:txBody>
@@ -1909,7 +3246,7 @@
           <a:lstStyle/>
           <a:p>
             <a:r>
-              <a:t>Conferimos com o que aconteceu em 2025: o modelo acertou a direção, mas foi conservador, porque 2025 teve um avanço amplo. A Bahia deu o maior salto do país e merece ser estudada. O modelo serve para priorizar e será recalibrado com os dados de 2025.</a:t>
+              <a:t>Conferimos com 2025: o modelo acertou a direção, mas foi conservador, porque 2025 teve um avanço amplo. A Bahia deu o maior salto do país e merece ser estudada. O modelo serve para priorizar.</a:t>
             </a:r>
           </a:p>
         </p:txBody>
@@ -2259,7 +3596,7 @@
           <a:lstStyle/>
           <a:p>
             <a:r>
-              <a:t>Cruzamos os dados de 3,3 milhões de crianças com cinco bases públicas e construímos dois modelos: o risco de cada criança e a chance de cada rede bater a meta. Tudo foi testado com dados que o modelo nunca viu.</a:t>
+              <a:t>Cruzamos os dados de 3,3 milhões de crianças com cinco bases públicas e construímos dois modelos: o risco de cada criança e a chance de cada rede bater a meta. Testamos com dados que o modelo nunca viu.</a:t>
             </a:r>
           </a:p>
         </p:txBody>
@@ -2399,7 +3736,7 @@
           <a:lstStyle/>
           <a:p>
             <a:r>
-              <a:t>Um exemplo: um município cearense com 76% das crianças na pobreza tem 95% de chance prevista, porque a rede tem abandono zero, quase nenhuma distorção e tempo integral.</a:t>
+              <a:t>Um exemplo, o caso mais extremo: um município cearense com 76% das crianças na pobreza tem 95% de chance prevista, porque a rede tem abandono zero, quase nenhuma distorção e tempo integral.</a:t>
             </a:r>
           </a:p>
         </p:txBody>
@@ -2469,7 +3806,7 @@
           <a:lstStyle/>
           <a:p>
             <a:r>
-              <a:t>Segunda pergunta: as variáveis mais influentes são o estado, a distorção idade-série, o abandono e o nível socioeconômico. Duas técnicas diferentes, SHAP e permutação, chegam ao mesmo ranking.</a:t>
+              <a:t>Segunda pergunta: as variáveis mais influentes são o estado, a distorção idade-série, o abandono e o nível socioeconômico. Dois testes diferentes chegam ao mesmo ranking.</a:t>
             </a:r>
           </a:p>
         </p:txBody>
@@ -2539,7 +3876,7 @@
           <a:lstStyle/>
           <a:p>
             <a:r>
-              <a:t>Descontado o contexto, o Ceará entrega muito mais do que sua renda prevê, efeito associado a quase 20 anos de colaboração com os municípios. E há limiares: acima de 8% de distorção ou de meio por cento de abandono, a chance cai.</a:t>
+              <a:t>Descontado o contexto, o Ceará entrega muito mais do que sua renda prevê. E há limiares: acima de 8% de distorção ou de meio por cento de abandono, a chance cai.</a:t>
             </a:r>
           </a:p>
         </p:txBody>
@@ -5709,7 +7046,7 @@
         </p:nvSpPr>
         <p:spPr>
           <a:xfrm>
-            <a:off x="548640" y="3977639"/>
+            <a:off x="548640" y="3246120"/>
             <a:ext cx="6583680" cy="914400"/>
           </a:xfrm>
           <a:prstGeom prst="rect">
@@ -5748,8 +7085,8 @@
         </p:nvSpPr>
         <p:spPr>
           <a:xfrm>
-            <a:off x="548640" y="5806440"/>
-            <a:ext cx="6583680" cy="365760"/>
+            <a:off x="548640" y="5257800"/>
+            <a:ext cx="6949440" cy="365760"/>
           </a:xfrm>
           <a:prstGeom prst="rect">
             <a:avLst/>
@@ -5768,6 +7105,45 @@
               </a:spcAft>
             </a:pPr>
             <a:r>
+              <a:rPr sz="1800" b="1" i="0">
+                <a:solidFill>
+                  <a:srgbClr val="FFFFFF"/>
+                </a:solidFill>
+                <a:latin typeface="Calibri"/>
+              </a:rPr>
+              <a:t>Elias Lopes Silva Junior</a:t>
+            </a:r>
+          </a:p>
+        </p:txBody>
+      </p:sp>
+      <p:sp>
+        <p:nvSpPr>
+          <p:cNvPr id="6" name="TextBox 5"/>
+          <p:cNvSpPr txBox="1"/>
+          <p:nvPr/>
+        </p:nvSpPr>
+        <p:spPr>
+          <a:xfrm>
+            <a:off x="548640" y="5669280"/>
+            <a:ext cx="6949440" cy="365760"/>
+          </a:xfrm>
+          <a:prstGeom prst="rect">
+            <a:avLst/>
+          </a:prstGeom>
+          <a:noFill/>
+        </p:spPr>
+        <p:txBody>
+          <a:bodyPr wrap="square" lIns="0" rIns="0" tIns="0" bIns="0" anchor="t">
+            <a:spAutoFit/>
+          </a:bodyPr>
+          <a:lstStyle/>
+          <a:p>
+            <a:pPr algn="l">
+              <a:spcAft>
+                <a:spcPts val="600"/>
+              </a:spcAft>
+            </a:pPr>
+            <a:r>
               <a:rPr sz="1300" b="0" i="0">
                 <a:solidFill>
                   <a:srgbClr val="CFE3E0"/>
@@ -5781,7 +7157,7 @@
       </p:sp>
       <p:sp>
         <p:nvSpPr>
-          <p:cNvPr id="6" name="Rounded Rectangle 5"/>
+          <p:cNvPr id="7" name="Rounded Rectangle 6"/>
           <p:cNvSpPr/>
           <p:nvPr/>
         </p:nvSpPr>
@@ -5827,7 +7203,7 @@
       </p:sp>
       <p:sp>
         <p:nvSpPr>
-          <p:cNvPr id="7" name="TextBox 6"/>
+          <p:cNvPr id="8" name="TextBox 7"/>
           <p:cNvSpPr txBox="1"/>
           <p:nvPr/>
         </p:nvSpPr>
@@ -5866,7 +7242,7 @@
       </p:sp>
       <p:sp>
         <p:nvSpPr>
-          <p:cNvPr id="8" name="TextBox 7"/>
+          <p:cNvPr id="9" name="TextBox 8"/>
           <p:cNvSpPr txBox="1"/>
           <p:nvPr/>
         </p:nvSpPr>
@@ -5923,7 +7299,46 @@
       <p:grpSpPr/>
       <p:sp>
         <p:nvSpPr>
-          <p:cNvPr id="2" name="Oval 1"/>
+          <p:cNvPr id="2" name="TextBox 1"/>
+          <p:cNvSpPr txBox="1"/>
+          <p:nvPr/>
+        </p:nvSpPr>
+        <p:spPr>
+          <a:xfrm>
+            <a:off x="548640" y="6473952"/>
+            <a:ext cx="11094415" cy="274320"/>
+          </a:xfrm>
+          <a:prstGeom prst="rect">
+            <a:avLst/>
+          </a:prstGeom>
+          <a:noFill/>
+        </p:spPr>
+        <p:txBody>
+          <a:bodyPr wrap="square" lIns="0" rIns="0" tIns="0" bIns="0" anchor="t">
+            <a:spAutoFit/>
+          </a:bodyPr>
+          <a:lstStyle/>
+          <a:p>
+            <a:pPr algn="l">
+              <a:spcAft>
+                <a:spcPts val="600"/>
+              </a:spcAft>
+            </a:pPr>
+            <a:r>
+              <a:rPr sz="900" b="0" i="0">
+                <a:solidFill>
+                  <a:srgbClr val="5B6B72"/>
+                </a:solidFill>
+                <a:latin typeface="Calibri"/>
+              </a:rPr>
+              <a:t>Fonte: Inep (Avaliação de Alfabetização 2023-2024, metas e resultados 2025), via Base dos Dados; Censo Escolar, IBGE e Atlas do Desenvolvimento Humano. Elaboração própria.</a:t>
+            </a:r>
+          </a:p>
+        </p:txBody>
+      </p:sp>
+      <p:sp>
+        <p:nvSpPr>
+          <p:cNvPr id="3" name="Oval 2"/>
           <p:cNvSpPr/>
           <p:nvPr/>
         </p:nvSpPr>
@@ -5976,7 +7391,7 @@
       </p:sp>
       <p:sp>
         <p:nvSpPr>
-          <p:cNvPr id="3" name="TextBox 2"/>
+          <p:cNvPr id="4" name="TextBox 3"/>
           <p:cNvSpPr txBox="1"/>
           <p:nvPr/>
         </p:nvSpPr>
@@ -6015,7 +7430,7 @@
       </p:sp>
       <p:sp>
         <p:nvSpPr>
-          <p:cNvPr id="4" name="TextBox 3"/>
+          <p:cNvPr id="5" name="TextBox 4"/>
           <p:cNvSpPr txBox="1"/>
           <p:nvPr/>
         </p:nvSpPr>
@@ -6054,7 +7469,7 @@
       </p:sp>
       <p:graphicFrame>
         <p:nvGraphicFramePr>
-          <p:cNvPr id="5" name="Table 4"/>
+          <p:cNvPr id="6" name="Table 5"/>
           <p:cNvGraphicFramePr>
             <a:graphicFrameLocks noGrp="1"/>
           </p:cNvGraphicFramePr>
@@ -7344,7 +8759,7 @@
       </p:graphicFrame>
       <p:sp>
         <p:nvSpPr>
-          <p:cNvPr id="6" name="Rounded Rectangle 5"/>
+          <p:cNvPr id="7" name="Rounded Rectangle 6"/>
           <p:cNvSpPr/>
           <p:nvPr/>
         </p:nvSpPr>
@@ -7390,7 +8805,7 @@
       </p:sp>
       <p:sp>
         <p:nvSpPr>
-          <p:cNvPr id="7" name="TextBox 6"/>
+          <p:cNvPr id="8" name="TextBox 7"/>
           <p:cNvSpPr txBox="1"/>
           <p:nvPr/>
         </p:nvSpPr>
@@ -7429,7 +8844,7 @@
       </p:sp>
       <p:sp>
         <p:nvSpPr>
-          <p:cNvPr id="8" name="TextBox 7"/>
+          <p:cNvPr id="9" name="TextBox 8"/>
           <p:cNvSpPr txBox="1"/>
           <p:nvPr/>
         </p:nvSpPr>
@@ -7503,7 +8918,7 @@
       </p:sp>
       <p:sp>
         <p:nvSpPr>
-          <p:cNvPr id="9" name="TextBox 8"/>
+          <p:cNvPr id="10" name="TextBox 9"/>
           <p:cNvSpPr txBox="1"/>
           <p:nvPr/>
         </p:nvSpPr>
@@ -7560,7 +8975,46 @@
       <p:grpSpPr/>
       <p:sp>
         <p:nvSpPr>
-          <p:cNvPr id="2" name="Oval 1"/>
+          <p:cNvPr id="2" name="TextBox 1"/>
+          <p:cNvSpPr txBox="1"/>
+          <p:nvPr/>
+        </p:nvSpPr>
+        <p:spPr>
+          <a:xfrm>
+            <a:off x="548640" y="6473952"/>
+            <a:ext cx="11094415" cy="274320"/>
+          </a:xfrm>
+          <a:prstGeom prst="rect">
+            <a:avLst/>
+          </a:prstGeom>
+          <a:noFill/>
+        </p:spPr>
+        <p:txBody>
+          <a:bodyPr wrap="square" lIns="0" rIns="0" tIns="0" bIns="0" anchor="t">
+            <a:spAutoFit/>
+          </a:bodyPr>
+          <a:lstStyle/>
+          <a:p>
+            <a:pPr algn="l">
+              <a:spcAft>
+                <a:spcPts val="600"/>
+              </a:spcAft>
+            </a:pPr>
+            <a:r>
+              <a:rPr sz="900" b="0" i="0">
+                <a:solidFill>
+                  <a:srgbClr val="5B6B72"/>
+                </a:solidFill>
+                <a:latin typeface="Calibri"/>
+              </a:rPr>
+              <a:t>Fonte: Inep (Avaliação de Alfabetização 2023-2024, metas e resultados 2025), via Base dos Dados; Censo Escolar, IBGE e Atlas do Desenvolvimento Humano. Elaboração própria.</a:t>
+            </a:r>
+          </a:p>
+        </p:txBody>
+      </p:sp>
+      <p:sp>
+        <p:nvSpPr>
+          <p:cNvPr id="3" name="Oval 2"/>
           <p:cNvSpPr/>
           <p:nvPr/>
         </p:nvSpPr>
@@ -7613,7 +9067,7 @@
       </p:sp>
       <p:sp>
         <p:nvSpPr>
-          <p:cNvPr id="3" name="TextBox 2"/>
+          <p:cNvPr id="4" name="TextBox 3"/>
           <p:cNvSpPr txBox="1"/>
           <p:nvPr/>
         </p:nvSpPr>
@@ -7652,7 +9106,7 @@
       </p:sp>
       <p:sp>
         <p:nvSpPr>
-          <p:cNvPr id="4" name="TextBox 3"/>
+          <p:cNvPr id="5" name="TextBox 4"/>
           <p:cNvSpPr txBox="1"/>
           <p:nvPr/>
         </p:nvSpPr>
@@ -7691,7 +9145,7 @@
       </p:sp>
       <p:sp>
         <p:nvSpPr>
-          <p:cNvPr id="5" name="TextBox 4"/>
+          <p:cNvPr id="6" name="TextBox 5"/>
           <p:cNvSpPr txBox="1"/>
           <p:nvPr/>
         </p:nvSpPr>
@@ -7739,7 +9193,7 @@
       </p:sp>
       <p:pic>
         <p:nvPicPr>
-          <p:cNvPr id="6" name="Picture 5" descr="app_03_mapa_risco.png"/>
+          <p:cNvPr id="7" name="Picture 6" descr="Mapa do Brasil com o índice de risco de cada rede municipal; o risco alto se concentra na Bahia e no Norte"/>
           <p:cNvPicPr>
             <a:picLocks noChangeAspect="1"/>
           </p:cNvPicPr>
@@ -7753,8 +9207,8 @@
         </p:blipFill>
         <p:spPr>
           <a:xfrm>
-            <a:off x="548640" y="2408292"/>
-            <a:ext cx="4572000" cy="3733055"/>
+            <a:off x="821555" y="2103120"/>
+            <a:ext cx="4026170" cy="4206240"/>
           </a:xfrm>
           <a:prstGeom prst="rect">
             <a:avLst/>
@@ -7763,7 +9217,7 @@
       </p:pic>
       <p:sp>
         <p:nvSpPr>
-          <p:cNvPr id="7" name="Rounded Rectangle 6"/>
+          <p:cNvPr id="8" name="Rounded Rectangle 7"/>
           <p:cNvSpPr/>
           <p:nvPr/>
         </p:nvSpPr>
@@ -7809,7 +9263,7 @@
       </p:sp>
       <p:sp>
         <p:nvSpPr>
-          <p:cNvPr id="8" name="TextBox 7"/>
+          <p:cNvPr id="9" name="TextBox 8"/>
           <p:cNvSpPr txBox="1"/>
           <p:nvPr/>
         </p:nvSpPr>
@@ -7848,7 +9302,7 @@
       </p:sp>
       <p:sp>
         <p:nvSpPr>
-          <p:cNvPr id="9" name="TextBox 8"/>
+          <p:cNvPr id="10" name="TextBox 9"/>
           <p:cNvSpPr txBox="1"/>
           <p:nvPr/>
         </p:nvSpPr>
@@ -7887,7 +9341,7 @@
       </p:sp>
       <p:sp>
         <p:nvSpPr>
-          <p:cNvPr id="10" name="TextBox 9"/>
+          <p:cNvPr id="11" name="TextBox 10"/>
           <p:cNvSpPr txBox="1"/>
           <p:nvPr/>
         </p:nvSpPr>
@@ -7926,7 +9380,7 @@
       </p:sp>
       <p:sp>
         <p:nvSpPr>
-          <p:cNvPr id="11" name="TextBox 10"/>
+          <p:cNvPr id="12" name="TextBox 11"/>
           <p:cNvSpPr txBox="1"/>
           <p:nvPr/>
         </p:nvSpPr>
@@ -7965,7 +9419,7 @@
       </p:sp>
       <p:sp>
         <p:nvSpPr>
-          <p:cNvPr id="12" name="TextBox 11"/>
+          <p:cNvPr id="13" name="TextBox 12"/>
           <p:cNvSpPr txBox="1"/>
           <p:nvPr/>
         </p:nvSpPr>
@@ -8004,7 +9458,7 @@
       </p:sp>
       <p:sp>
         <p:nvSpPr>
-          <p:cNvPr id="13" name="TextBox 12"/>
+          <p:cNvPr id="14" name="TextBox 13"/>
           <p:cNvSpPr txBox="1"/>
           <p:nvPr/>
         </p:nvSpPr>
@@ -8043,7 +9497,7 @@
       </p:sp>
       <p:sp>
         <p:nvSpPr>
-          <p:cNvPr id="14" name="TextBox 13"/>
+          <p:cNvPr id="15" name="TextBox 14"/>
           <p:cNvSpPr txBox="1"/>
           <p:nvPr/>
         </p:nvSpPr>
@@ -8082,7 +9536,7 @@
       </p:sp>
       <p:sp>
         <p:nvSpPr>
-          <p:cNvPr id="15" name="TextBox 14"/>
+          <p:cNvPr id="16" name="TextBox 15"/>
           <p:cNvSpPr txBox="1"/>
           <p:nvPr/>
         </p:nvSpPr>
@@ -8121,7 +9575,7 @@
       </p:sp>
       <p:sp>
         <p:nvSpPr>
-          <p:cNvPr id="16" name="TextBox 15"/>
+          <p:cNvPr id="17" name="TextBox 16"/>
           <p:cNvSpPr txBox="1"/>
           <p:nvPr/>
         </p:nvSpPr>
@@ -8160,7 +9614,7 @@
       </p:sp>
       <p:sp>
         <p:nvSpPr>
-          <p:cNvPr id="17" name="TextBox 16"/>
+          <p:cNvPr id="18" name="TextBox 17"/>
           <p:cNvSpPr txBox="1"/>
           <p:nvPr/>
         </p:nvSpPr>
@@ -8199,7 +9653,7 @@
       </p:sp>
       <p:sp>
         <p:nvSpPr>
-          <p:cNvPr id="18" name="TextBox 17"/>
+          <p:cNvPr id="19" name="TextBox 18"/>
           <p:cNvSpPr txBox="1"/>
           <p:nvPr/>
         </p:nvSpPr>
@@ -8238,7 +9692,7 @@
       </p:sp>
       <p:sp>
         <p:nvSpPr>
-          <p:cNvPr id="19" name="TextBox 18"/>
+          <p:cNvPr id="20" name="TextBox 19"/>
           <p:cNvSpPr txBox="1"/>
           <p:nvPr/>
         </p:nvSpPr>
@@ -8277,7 +9731,7 @@
       </p:sp>
       <p:sp>
         <p:nvSpPr>
-          <p:cNvPr id="20" name="Rounded Rectangle 19"/>
+          <p:cNvPr id="21" name="Rounded Rectangle 20"/>
           <p:cNvSpPr/>
           <p:nvPr/>
         </p:nvSpPr>
@@ -8323,7 +9777,7 @@
       </p:sp>
       <p:sp>
         <p:nvSpPr>
-          <p:cNvPr id="21" name="TextBox 20"/>
+          <p:cNvPr id="22" name="TextBox 21"/>
           <p:cNvSpPr txBox="1"/>
           <p:nvPr/>
         </p:nvSpPr>
@@ -8362,7 +9816,7 @@
       </p:sp>
       <p:sp>
         <p:nvSpPr>
-          <p:cNvPr id="22" name="TextBox 21"/>
+          <p:cNvPr id="23" name="TextBox 22"/>
           <p:cNvSpPr txBox="1"/>
           <p:nvPr/>
         </p:nvSpPr>
@@ -8401,7 +9855,7 @@
       </p:sp>
       <p:sp>
         <p:nvSpPr>
-          <p:cNvPr id="23" name="TextBox 22"/>
+          <p:cNvPr id="24" name="TextBox 23"/>
           <p:cNvSpPr txBox="1"/>
           <p:nvPr/>
         </p:nvSpPr>
@@ -8440,7 +9894,7 @@
       </p:sp>
       <p:sp>
         <p:nvSpPr>
-          <p:cNvPr id="24" name="TextBox 23"/>
+          <p:cNvPr id="25" name="TextBox 24"/>
           <p:cNvSpPr txBox="1"/>
           <p:nvPr/>
         </p:nvSpPr>
@@ -8479,7 +9933,7 @@
       </p:sp>
       <p:sp>
         <p:nvSpPr>
-          <p:cNvPr id="25" name="TextBox 24"/>
+          <p:cNvPr id="26" name="TextBox 25"/>
           <p:cNvSpPr txBox="1"/>
           <p:nvPr/>
         </p:nvSpPr>
@@ -8518,7 +9972,7 @@
       </p:sp>
       <p:sp>
         <p:nvSpPr>
-          <p:cNvPr id="26" name="TextBox 25"/>
+          <p:cNvPr id="27" name="TextBox 26"/>
           <p:cNvSpPr txBox="1"/>
           <p:nvPr/>
         </p:nvSpPr>
@@ -8557,7 +10011,7 @@
       </p:sp>
       <p:sp>
         <p:nvSpPr>
-          <p:cNvPr id="27" name="TextBox 26"/>
+          <p:cNvPr id="28" name="TextBox 27"/>
           <p:cNvSpPr txBox="1"/>
           <p:nvPr/>
         </p:nvSpPr>
@@ -8596,7 +10050,7 @@
       </p:sp>
       <p:sp>
         <p:nvSpPr>
-          <p:cNvPr id="28" name="TextBox 27"/>
+          <p:cNvPr id="29" name="TextBox 28"/>
           <p:cNvSpPr txBox="1"/>
           <p:nvPr/>
         </p:nvSpPr>
@@ -8635,7 +10089,7 @@
       </p:sp>
       <p:sp>
         <p:nvSpPr>
-          <p:cNvPr id="29" name="TextBox 28"/>
+          <p:cNvPr id="30" name="TextBox 29"/>
           <p:cNvSpPr txBox="1"/>
           <p:nvPr/>
         </p:nvSpPr>
@@ -8674,7 +10128,7 @@
       </p:sp>
       <p:sp>
         <p:nvSpPr>
-          <p:cNvPr id="30" name="TextBox 29"/>
+          <p:cNvPr id="31" name="TextBox 30"/>
           <p:cNvSpPr txBox="1"/>
           <p:nvPr/>
         </p:nvSpPr>
@@ -8713,7 +10167,7 @@
       </p:sp>
       <p:sp>
         <p:nvSpPr>
-          <p:cNvPr id="31" name="TextBox 30"/>
+          <p:cNvPr id="32" name="TextBox 31"/>
           <p:cNvSpPr txBox="1"/>
           <p:nvPr/>
         </p:nvSpPr>
@@ -8770,7 +10224,46 @@
       <p:grpSpPr/>
       <p:sp>
         <p:nvSpPr>
-          <p:cNvPr id="2" name="Oval 1"/>
+          <p:cNvPr id="2" name="TextBox 1"/>
+          <p:cNvSpPr txBox="1"/>
+          <p:nvPr/>
+        </p:nvSpPr>
+        <p:spPr>
+          <a:xfrm>
+            <a:off x="548640" y="6473952"/>
+            <a:ext cx="11094415" cy="274320"/>
+          </a:xfrm>
+          <a:prstGeom prst="rect">
+            <a:avLst/>
+          </a:prstGeom>
+          <a:noFill/>
+        </p:spPr>
+        <p:txBody>
+          <a:bodyPr wrap="square" lIns="0" rIns="0" tIns="0" bIns="0" anchor="t">
+            <a:spAutoFit/>
+          </a:bodyPr>
+          <a:lstStyle/>
+          <a:p>
+            <a:pPr algn="l">
+              <a:spcAft>
+                <a:spcPts val="600"/>
+              </a:spcAft>
+            </a:pPr>
+            <a:r>
+              <a:rPr sz="900" b="0" i="0">
+                <a:solidFill>
+                  <a:srgbClr val="5B6B72"/>
+                </a:solidFill>
+                <a:latin typeface="Calibri"/>
+              </a:rPr>
+              <a:t>Fonte: Inep (Avaliação de Alfabetização 2023-2024, metas e resultados 2025), via Base dos Dados; Censo Escolar, IBGE e Atlas do Desenvolvimento Humano. Elaboração própria.</a:t>
+            </a:r>
+          </a:p>
+        </p:txBody>
+      </p:sp>
+      <p:sp>
+        <p:nvSpPr>
+          <p:cNvPr id="3" name="Oval 2"/>
           <p:cNvSpPr/>
           <p:nvPr/>
         </p:nvSpPr>
@@ -8823,7 +10316,7 @@
       </p:sp>
       <p:sp>
         <p:nvSpPr>
-          <p:cNvPr id="3" name="TextBox 2"/>
+          <p:cNvPr id="4" name="TextBox 3"/>
           <p:cNvSpPr txBox="1"/>
           <p:nvPr/>
         </p:nvSpPr>
@@ -8862,7 +10355,7 @@
       </p:sp>
       <p:sp>
         <p:nvSpPr>
-          <p:cNvPr id="4" name="TextBox 3"/>
+          <p:cNvPr id="5" name="TextBox 4"/>
           <p:cNvSpPr txBox="1"/>
           <p:nvPr/>
         </p:nvSpPr>
@@ -8901,7 +10394,7 @@
       </p:sp>
       <p:graphicFrame>
         <p:nvGraphicFramePr>
-          <p:cNvPr id="5" name="Table 4"/>
+          <p:cNvPr id="6" name="Table 5"/>
           <p:cNvGraphicFramePr>
             <a:graphicFrameLocks noGrp="1"/>
           </p:cNvGraphicFramePr>
@@ -10191,7 +11684,7 @@
       </p:graphicFrame>
       <p:sp>
         <p:nvSpPr>
-          <p:cNvPr id="6" name="TextBox 5"/>
+          <p:cNvPr id="7" name="TextBox 6"/>
           <p:cNvSpPr txBox="1"/>
           <p:nvPr/>
         </p:nvSpPr>
@@ -10230,7 +11723,7 @@
       </p:sp>
       <p:sp>
         <p:nvSpPr>
-          <p:cNvPr id="7" name="TextBox 6"/>
+          <p:cNvPr id="8" name="TextBox 7"/>
           <p:cNvSpPr txBox="1"/>
           <p:nvPr/>
         </p:nvSpPr>
@@ -10269,7 +11762,7 @@
       </p:sp>
       <p:sp>
         <p:nvSpPr>
-          <p:cNvPr id="8" name="TextBox 7"/>
+          <p:cNvPr id="9" name="TextBox 8"/>
           <p:cNvSpPr txBox="1"/>
           <p:nvPr/>
         </p:nvSpPr>
@@ -10308,7 +11801,7 @@
       </p:sp>
       <p:sp>
         <p:nvSpPr>
-          <p:cNvPr id="9" name="TextBox 8"/>
+          <p:cNvPr id="10" name="TextBox 9"/>
           <p:cNvSpPr txBox="1"/>
           <p:nvPr/>
         </p:nvSpPr>
@@ -10347,7 +11840,7 @@
       </p:sp>
       <p:sp>
         <p:nvSpPr>
-          <p:cNvPr id="10" name="Rounded Rectangle 9"/>
+          <p:cNvPr id="11" name="Rounded Rectangle 10"/>
           <p:cNvSpPr/>
           <p:nvPr/>
         </p:nvSpPr>
@@ -10393,7 +11886,7 @@
       </p:sp>
       <p:sp>
         <p:nvSpPr>
-          <p:cNvPr id="11" name="TextBox 10"/>
+          <p:cNvPr id="12" name="TextBox 11"/>
           <p:cNvSpPr txBox="1"/>
           <p:nvPr/>
         </p:nvSpPr>
@@ -10450,7 +11943,46 @@
       <p:grpSpPr/>
       <p:sp>
         <p:nvSpPr>
-          <p:cNvPr id="2" name="Oval 1"/>
+          <p:cNvPr id="2" name="TextBox 1"/>
+          <p:cNvSpPr txBox="1"/>
+          <p:nvPr/>
+        </p:nvSpPr>
+        <p:spPr>
+          <a:xfrm>
+            <a:off x="548640" y="6473952"/>
+            <a:ext cx="11094415" cy="274320"/>
+          </a:xfrm>
+          <a:prstGeom prst="rect">
+            <a:avLst/>
+          </a:prstGeom>
+          <a:noFill/>
+        </p:spPr>
+        <p:txBody>
+          <a:bodyPr wrap="square" lIns="0" rIns="0" tIns="0" bIns="0" anchor="t">
+            <a:spAutoFit/>
+          </a:bodyPr>
+          <a:lstStyle/>
+          <a:p>
+            <a:pPr algn="l">
+              <a:spcAft>
+                <a:spcPts val="600"/>
+              </a:spcAft>
+            </a:pPr>
+            <a:r>
+              <a:rPr sz="900" b="0" i="0">
+                <a:solidFill>
+                  <a:srgbClr val="5B6B72"/>
+                </a:solidFill>
+                <a:latin typeface="Calibri"/>
+              </a:rPr>
+              <a:t>Fonte: Inep (Avaliação de Alfabetização 2023-2024, metas e resultados 2025), via Base dos Dados; Censo Escolar, IBGE e Atlas do Desenvolvimento Humano. Elaboração própria.</a:t>
+            </a:r>
+          </a:p>
+        </p:txBody>
+      </p:sp>
+      <p:sp>
+        <p:nvSpPr>
+          <p:cNvPr id="3" name="Oval 2"/>
           <p:cNvSpPr/>
           <p:nvPr/>
         </p:nvSpPr>
@@ -10503,7 +12035,7 @@
       </p:sp>
       <p:sp>
         <p:nvSpPr>
-          <p:cNvPr id="3" name="TextBox 2"/>
+          <p:cNvPr id="4" name="TextBox 3"/>
           <p:cNvSpPr txBox="1"/>
           <p:nvPr/>
         </p:nvSpPr>
@@ -10542,7 +12074,7 @@
       </p:sp>
       <p:sp>
         <p:nvSpPr>
-          <p:cNvPr id="4" name="TextBox 3"/>
+          <p:cNvPr id="5" name="TextBox 4"/>
           <p:cNvSpPr txBox="1"/>
           <p:nvPr/>
         </p:nvSpPr>
@@ -10581,7 +12113,7 @@
       </p:sp>
       <p:sp>
         <p:nvSpPr>
-          <p:cNvPr id="5" name="TextBox 4"/>
+          <p:cNvPr id="6" name="TextBox 5"/>
           <p:cNvSpPr txBox="1"/>
           <p:nvPr/>
         </p:nvSpPr>
@@ -10629,7 +12161,7 @@
       </p:sp>
       <p:sp>
         <p:nvSpPr>
-          <p:cNvPr id="6" name="Oval 5"/>
+          <p:cNvPr id="7" name="Oval 6"/>
           <p:cNvSpPr/>
           <p:nvPr/>
         </p:nvSpPr>
@@ -10682,7 +12214,7 @@
       </p:sp>
       <p:sp>
         <p:nvSpPr>
-          <p:cNvPr id="7" name="TextBox 6"/>
+          <p:cNvPr id="8" name="TextBox 7"/>
           <p:cNvSpPr txBox="1"/>
           <p:nvPr/>
         </p:nvSpPr>
@@ -10730,7 +12262,7 @@
       </p:sp>
       <p:sp>
         <p:nvSpPr>
-          <p:cNvPr id="8" name="Oval 7"/>
+          <p:cNvPr id="9" name="Oval 8"/>
           <p:cNvSpPr/>
           <p:nvPr/>
         </p:nvSpPr>
@@ -10783,7 +12315,7 @@
       </p:sp>
       <p:sp>
         <p:nvSpPr>
-          <p:cNvPr id="9" name="TextBox 8"/>
+          <p:cNvPr id="10" name="TextBox 9"/>
           <p:cNvSpPr txBox="1"/>
           <p:nvPr/>
         </p:nvSpPr>
@@ -10831,7 +12363,7 @@
       </p:sp>
       <p:sp>
         <p:nvSpPr>
-          <p:cNvPr id="10" name="Oval 9"/>
+          <p:cNvPr id="11" name="Oval 10"/>
           <p:cNvSpPr/>
           <p:nvPr/>
         </p:nvSpPr>
@@ -10884,7 +12416,7 @@
       </p:sp>
       <p:sp>
         <p:nvSpPr>
-          <p:cNvPr id="11" name="TextBox 10"/>
+          <p:cNvPr id="12" name="TextBox 11"/>
           <p:cNvSpPr txBox="1"/>
           <p:nvPr/>
         </p:nvSpPr>
@@ -10932,7 +12464,7 @@
       </p:sp>
       <p:sp>
         <p:nvSpPr>
-          <p:cNvPr id="12" name="TextBox 11"/>
+          <p:cNvPr id="13" name="TextBox 12"/>
           <p:cNvSpPr txBox="1"/>
           <p:nvPr/>
         </p:nvSpPr>
@@ -10971,7 +12503,7 @@
       </p:sp>
       <p:sp>
         <p:nvSpPr>
-          <p:cNvPr id="13" name="TextBox 12"/>
+          <p:cNvPr id="14" name="TextBox 13"/>
           <p:cNvSpPr txBox="1"/>
           <p:nvPr/>
         </p:nvSpPr>
@@ -11010,7 +12542,7 @@
       </p:sp>
       <p:sp>
         <p:nvSpPr>
-          <p:cNvPr id="14" name="TextBox 13"/>
+          <p:cNvPr id="15" name="TextBox 14"/>
           <p:cNvSpPr txBox="1"/>
           <p:nvPr/>
         </p:nvSpPr>
@@ -11049,7 +12581,7 @@
       </p:sp>
       <p:sp>
         <p:nvSpPr>
-          <p:cNvPr id="15" name="TextBox 14"/>
+          <p:cNvPr id="16" name="TextBox 15"/>
           <p:cNvSpPr txBox="1"/>
           <p:nvPr/>
         </p:nvSpPr>
@@ -11086,30 +12618,24 @@
           </a:p>
         </p:txBody>
       </p:sp>
-      <p:pic>
-        <p:nvPicPr>
-          <p:cNvPr id="16" name="Picture 15" descr="app_00_choques_estaduais.png"/>
-          <p:cNvPicPr>
-            <a:picLocks noChangeAspect="1"/>
-          </p:cNvPicPr>
-          <p:nvPr/>
-        </p:nvPicPr>
-        <p:blipFill>
-          <a:blip r:embed="rId2"/>
-          <a:stretch>
-            <a:fillRect/>
-          </a:stretch>
-        </p:blipFill>
-        <p:spPr>
-          <a:xfrm>
-            <a:off x="5850427" y="2103120"/>
-            <a:ext cx="5489865" cy="4434840"/>
-          </a:xfrm>
-          <a:prstGeom prst="rect">
-            <a:avLst/>
-          </a:prstGeom>
-        </p:spPr>
-      </p:pic>
+      <p:graphicFrame>
+        <p:nvGraphicFramePr>
+          <p:cNvPr id="17" name="Chart 16"/>
+          <p:cNvGraphicFramePr>
+            <a:graphicFrameLocks noGrp="1"/>
+          </p:cNvGraphicFramePr>
+          <p:nvPr/>
+        </p:nvGraphicFramePr>
+        <p:xfrm>
+          <a:off x="5760720" y="2103120"/>
+          <a:ext cx="5852160" cy="4251960"/>
+        </p:xfrm>
+        <a:graphic>
+          <a:graphicData uri="http://schemas.openxmlformats.org/drawingml/2006/chart">
+            <c:chart xmlns:c="http://schemas.openxmlformats.org/drawingml/2006/chart" r:id="rId2"/>
+          </a:graphicData>
+        </a:graphic>
+      </p:graphicFrame>
     </p:spTree>
   </p:cSld>
   <p:clrMapOvr>
@@ -11130,7 +12656,46 @@
       <p:grpSpPr/>
       <p:sp>
         <p:nvSpPr>
-          <p:cNvPr id="2" name="Oval 1"/>
+          <p:cNvPr id="2" name="TextBox 1"/>
+          <p:cNvSpPr txBox="1"/>
+          <p:nvPr/>
+        </p:nvSpPr>
+        <p:spPr>
+          <a:xfrm>
+            <a:off x="548640" y="6473952"/>
+            <a:ext cx="11094415" cy="274320"/>
+          </a:xfrm>
+          <a:prstGeom prst="rect">
+            <a:avLst/>
+          </a:prstGeom>
+          <a:noFill/>
+        </p:spPr>
+        <p:txBody>
+          <a:bodyPr wrap="square" lIns="0" rIns="0" tIns="0" bIns="0" anchor="t">
+            <a:spAutoFit/>
+          </a:bodyPr>
+          <a:lstStyle/>
+          <a:p>
+            <a:pPr algn="l">
+              <a:spcAft>
+                <a:spcPts val="600"/>
+              </a:spcAft>
+            </a:pPr>
+            <a:r>
+              <a:rPr sz="900" b="0" i="0">
+                <a:solidFill>
+                  <a:srgbClr val="5B6B72"/>
+                </a:solidFill>
+                <a:latin typeface="Calibri"/>
+              </a:rPr>
+              <a:t>Fonte: Inep (Avaliação de Alfabetização 2023-2024, metas e resultados 2025), via Base dos Dados; Censo Escolar, IBGE e Atlas do Desenvolvimento Humano. Elaboração própria.</a:t>
+            </a:r>
+          </a:p>
+        </p:txBody>
+      </p:sp>
+      <p:sp>
+        <p:nvSpPr>
+          <p:cNvPr id="3" name="Oval 2"/>
           <p:cNvSpPr/>
           <p:nvPr/>
         </p:nvSpPr>
@@ -11183,7 +12748,7 @@
       </p:sp>
       <p:sp>
         <p:nvSpPr>
-          <p:cNvPr id="3" name="TextBox 2"/>
+          <p:cNvPr id="4" name="TextBox 3"/>
           <p:cNvSpPr txBox="1"/>
           <p:nvPr/>
         </p:nvSpPr>
@@ -11222,7 +12787,7 @@
       </p:sp>
       <p:sp>
         <p:nvSpPr>
-          <p:cNvPr id="4" name="TextBox 3"/>
+          <p:cNvPr id="5" name="TextBox 4"/>
           <p:cNvSpPr txBox="1"/>
           <p:nvPr/>
         </p:nvSpPr>
@@ -11261,7 +12826,7 @@
       </p:sp>
       <p:pic>
         <p:nvPicPr>
-          <p:cNvPr id="5" name="Picture 4" descr="eda_12_metas_estaduais.png"/>
+          <p:cNvPr id="6" name="Picture 5" descr="Resultado de 2024 e de 2025 de cada estado comparado com a meta de 2025; 20 de 26 estados bateram a meta"/>
           <p:cNvPicPr>
             <a:picLocks noChangeAspect="1"/>
           </p:cNvPicPr>
@@ -11275,8 +12840,8 @@
         </p:blipFill>
         <p:spPr>
           <a:xfrm>
-            <a:off x="569543" y="1691640"/>
-            <a:ext cx="4895953" cy="4892040"/>
+            <a:off x="638178" y="1691640"/>
+            <a:ext cx="4758683" cy="4754880"/>
           </a:xfrm>
           <a:prstGeom prst="rect">
             <a:avLst/>
@@ -11285,7 +12850,7 @@
       </p:pic>
       <p:sp>
         <p:nvSpPr>
-          <p:cNvPr id="6" name="TextBox 5"/>
+          <p:cNvPr id="7" name="TextBox 6"/>
           <p:cNvSpPr txBox="1"/>
           <p:nvPr/>
         </p:nvSpPr>
@@ -11324,7 +12889,7 @@
       </p:sp>
       <p:sp>
         <p:nvSpPr>
-          <p:cNvPr id="7" name="TextBox 6"/>
+          <p:cNvPr id="8" name="TextBox 7"/>
           <p:cNvSpPr txBox="1"/>
           <p:nvPr/>
         </p:nvSpPr>
@@ -11363,7 +12928,7 @@
       </p:sp>
       <p:sp>
         <p:nvSpPr>
-          <p:cNvPr id="8" name="TextBox 7"/>
+          <p:cNvPr id="9" name="TextBox 8"/>
           <p:cNvSpPr txBox="1"/>
           <p:nvPr/>
         </p:nvSpPr>
@@ -11402,7 +12967,7 @@
       </p:sp>
       <p:sp>
         <p:nvSpPr>
-          <p:cNvPr id="9" name="TextBox 8"/>
+          <p:cNvPr id="10" name="TextBox 9"/>
           <p:cNvSpPr txBox="1"/>
           <p:nvPr/>
         </p:nvSpPr>
@@ -11441,7 +13006,7 @@
       </p:sp>
       <p:sp>
         <p:nvSpPr>
-          <p:cNvPr id="10" name="Rounded Rectangle 9"/>
+          <p:cNvPr id="11" name="Rounded Rectangle 10"/>
           <p:cNvSpPr/>
           <p:nvPr/>
         </p:nvSpPr>
@@ -11487,7 +13052,7 @@
       </p:sp>
       <p:sp>
         <p:nvSpPr>
-          <p:cNvPr id="11" name="TextBox 10"/>
+          <p:cNvPr id="12" name="TextBox 11"/>
           <p:cNvSpPr txBox="1"/>
           <p:nvPr/>
         </p:nvSpPr>
@@ -11612,8 +13177,8 @@
         </p:nvSpPr>
         <p:spPr>
           <a:xfrm>
-            <a:off x="548640" y="384048"/>
-            <a:ext cx="10058400" cy="365760"/>
+            <a:off x="548640" y="6473952"/>
+            <a:ext cx="11094415" cy="274320"/>
           </a:xfrm>
           <a:prstGeom prst="rect">
             <a:avLst/>
@@ -11621,7 +13186,7 @@
           <a:noFill/>
         </p:spPr>
         <p:txBody>
-          <a:bodyPr wrap="square" lIns="0" rIns="0" tIns="0" bIns="0" anchor="ctr">
+          <a:bodyPr wrap="square" lIns="0" rIns="0" tIns="0" bIns="0" anchor="t">
             <a:spAutoFit/>
           </a:bodyPr>
           <a:lstStyle/>
@@ -11632,13 +13197,13 @@
               </a:spcAft>
             </a:pPr>
             <a:r>
-              <a:rPr sz="1400" b="1" i="0">
-                <a:solidFill>
-                  <a:srgbClr val="E76F51"/>
+              <a:rPr sz="900" b="0" i="0">
+                <a:solidFill>
+                  <a:srgbClr val="5B6B72"/>
                 </a:solidFill>
                 <a:latin typeface="Calibri"/>
               </a:rPr>
-              <a:t>VALOR ESTRATÉGICO PARA AS POLÍTICAS PÚBLICAS</a:t>
+              <a:t>Fonte: Inep (Avaliação de Alfabetização 2023-2024, metas e resultados 2025), via Base dos Dados; Censo Escolar, IBGE e Atlas do Desenvolvimento Humano. Elaboração própria.</a:t>
             </a:r>
           </a:p>
         </p:txBody>
@@ -11651,8 +13216,8 @@
         </p:nvSpPr>
         <p:spPr>
           <a:xfrm>
-            <a:off x="548640" y="841248"/>
-            <a:ext cx="11094415" cy="731520"/>
+            <a:off x="548640" y="384048"/>
+            <a:ext cx="10058400" cy="365760"/>
           </a:xfrm>
           <a:prstGeom prst="rect">
             <a:avLst/>
@@ -11660,7 +13225,7 @@
           <a:noFill/>
         </p:spPr>
         <p:txBody>
-          <a:bodyPr wrap="square" lIns="0" rIns="0" tIns="0" bIns="0" anchor="t">
+          <a:bodyPr wrap="square" lIns="0" rIns="0" tIns="0" bIns="0" anchor="ctr">
             <a:spAutoFit/>
           </a:bodyPr>
           <a:lstStyle/>
@@ -11671,6 +13236,45 @@
               </a:spcAft>
             </a:pPr>
             <a:r>
+              <a:rPr sz="1400" b="1" i="0">
+                <a:solidFill>
+                  <a:srgbClr val="E76F51"/>
+                </a:solidFill>
+                <a:latin typeface="Calibri"/>
+              </a:rPr>
+              <a:t>VALOR ESTRATÉGICO PARA AS POLÍTICAS PÚBLICAS</a:t>
+            </a:r>
+          </a:p>
+        </p:txBody>
+      </p:sp>
+      <p:sp>
+        <p:nvSpPr>
+          <p:cNvPr id="4" name="TextBox 3"/>
+          <p:cNvSpPr txBox="1"/>
+          <p:nvPr/>
+        </p:nvSpPr>
+        <p:spPr>
+          <a:xfrm>
+            <a:off x="548640" y="841248"/>
+            <a:ext cx="11094415" cy="731520"/>
+          </a:xfrm>
+          <a:prstGeom prst="rect">
+            <a:avLst/>
+          </a:prstGeom>
+          <a:noFill/>
+        </p:spPr>
+        <p:txBody>
+          <a:bodyPr wrap="square" lIns="0" rIns="0" tIns="0" bIns="0" anchor="t">
+            <a:spAutoFit/>
+          </a:bodyPr>
+          <a:lstStyle/>
+          <a:p>
+            <a:pPr algn="l">
+              <a:spcAft>
+                <a:spcPts val="600"/>
+              </a:spcAft>
+            </a:pPr>
+            <a:r>
               <a:rPr sz="3000" b="1" i="0">
                 <a:solidFill>
                   <a:srgbClr val="264653"/>
@@ -11684,7 +13288,7 @@
       </p:sp>
       <p:sp>
         <p:nvSpPr>
-          <p:cNvPr id="4" name="Rounded Rectangle 3"/>
+          <p:cNvPr id="5" name="Rounded Rectangle 4"/>
           <p:cNvSpPr/>
           <p:nvPr/>
         </p:nvSpPr>
@@ -11730,7 +13334,7 @@
       </p:sp>
       <p:sp>
         <p:nvSpPr>
-          <p:cNvPr id="5" name="Oval 4"/>
+          <p:cNvPr id="6" name="Oval 5"/>
           <p:cNvSpPr/>
           <p:nvPr/>
         </p:nvSpPr>
@@ -11783,7 +13387,7 @@
       </p:sp>
       <p:sp>
         <p:nvSpPr>
-          <p:cNvPr id="6" name="TextBox 5"/>
+          <p:cNvPr id="7" name="TextBox 6"/>
           <p:cNvSpPr txBox="1"/>
           <p:nvPr/>
         </p:nvSpPr>
@@ -11822,7 +13426,7 @@
       </p:sp>
       <p:sp>
         <p:nvSpPr>
-          <p:cNvPr id="7" name="TextBox 6"/>
+          <p:cNvPr id="8" name="TextBox 7"/>
           <p:cNvSpPr txBox="1"/>
           <p:nvPr/>
         </p:nvSpPr>
@@ -11861,7 +13465,7 @@
       </p:sp>
       <p:sp>
         <p:nvSpPr>
-          <p:cNvPr id="8" name="Rounded Rectangle 7"/>
+          <p:cNvPr id="9" name="Rounded Rectangle 8"/>
           <p:cNvSpPr/>
           <p:nvPr/>
         </p:nvSpPr>
@@ -11907,7 +13511,7 @@
       </p:sp>
       <p:sp>
         <p:nvSpPr>
-          <p:cNvPr id="9" name="Oval 8"/>
+          <p:cNvPr id="10" name="Oval 9"/>
           <p:cNvSpPr/>
           <p:nvPr/>
         </p:nvSpPr>
@@ -11960,7 +13564,7 @@
       </p:sp>
       <p:sp>
         <p:nvSpPr>
-          <p:cNvPr id="10" name="TextBox 9"/>
+          <p:cNvPr id="11" name="TextBox 10"/>
           <p:cNvSpPr txBox="1"/>
           <p:nvPr/>
         </p:nvSpPr>
@@ -11999,7 +13603,7 @@
       </p:sp>
       <p:sp>
         <p:nvSpPr>
-          <p:cNvPr id="11" name="TextBox 10"/>
+          <p:cNvPr id="12" name="TextBox 11"/>
           <p:cNvSpPr txBox="1"/>
           <p:nvPr/>
         </p:nvSpPr>
@@ -12038,7 +13642,7 @@
       </p:sp>
       <p:sp>
         <p:nvSpPr>
-          <p:cNvPr id="12" name="Rounded Rectangle 11"/>
+          <p:cNvPr id="13" name="Rounded Rectangle 12"/>
           <p:cNvSpPr/>
           <p:nvPr/>
         </p:nvSpPr>
@@ -12084,7 +13688,7 @@
       </p:sp>
       <p:sp>
         <p:nvSpPr>
-          <p:cNvPr id="13" name="Oval 12"/>
+          <p:cNvPr id="14" name="Oval 13"/>
           <p:cNvSpPr/>
           <p:nvPr/>
         </p:nvSpPr>
@@ -12137,7 +13741,7 @@
       </p:sp>
       <p:sp>
         <p:nvSpPr>
-          <p:cNvPr id="14" name="TextBox 13"/>
+          <p:cNvPr id="15" name="TextBox 14"/>
           <p:cNvSpPr txBox="1"/>
           <p:nvPr/>
         </p:nvSpPr>
@@ -12176,7 +13780,7 @@
       </p:sp>
       <p:sp>
         <p:nvSpPr>
-          <p:cNvPr id="15" name="TextBox 14"/>
+          <p:cNvPr id="16" name="TextBox 15"/>
           <p:cNvSpPr txBox="1"/>
           <p:nvPr/>
         </p:nvSpPr>
@@ -12215,7 +13819,7 @@
       </p:sp>
       <p:sp>
         <p:nvSpPr>
-          <p:cNvPr id="16" name="Rounded Rectangle 15"/>
+          <p:cNvPr id="17" name="Rounded Rectangle 16"/>
           <p:cNvSpPr/>
           <p:nvPr/>
         </p:nvSpPr>
@@ -12261,7 +13865,7 @@
       </p:sp>
       <p:sp>
         <p:nvSpPr>
-          <p:cNvPr id="17" name="Oval 16"/>
+          <p:cNvPr id="18" name="Oval 17"/>
           <p:cNvSpPr/>
           <p:nvPr/>
         </p:nvSpPr>
@@ -12314,7 +13918,7 @@
       </p:sp>
       <p:sp>
         <p:nvSpPr>
-          <p:cNvPr id="18" name="TextBox 17"/>
+          <p:cNvPr id="19" name="TextBox 18"/>
           <p:cNvSpPr txBox="1"/>
           <p:nvPr/>
         </p:nvSpPr>
@@ -12353,7 +13957,7 @@
       </p:sp>
       <p:sp>
         <p:nvSpPr>
-          <p:cNvPr id="19" name="TextBox 18"/>
+          <p:cNvPr id="20" name="TextBox 19"/>
           <p:cNvSpPr txBox="1"/>
           <p:nvPr/>
         </p:nvSpPr>
@@ -12392,7 +13996,7 @@
       </p:sp>
       <p:sp>
         <p:nvSpPr>
-          <p:cNvPr id="20" name="Rounded Rectangle 19"/>
+          <p:cNvPr id="21" name="Rounded Rectangle 20"/>
           <p:cNvSpPr/>
           <p:nvPr/>
         </p:nvSpPr>
@@ -12438,7 +14042,7 @@
       </p:sp>
       <p:sp>
         <p:nvSpPr>
-          <p:cNvPr id="21" name="Oval 20"/>
+          <p:cNvPr id="22" name="Oval 21"/>
           <p:cNvSpPr/>
           <p:nvPr/>
         </p:nvSpPr>
@@ -12491,7 +14095,7 @@
       </p:sp>
       <p:sp>
         <p:nvSpPr>
-          <p:cNvPr id="22" name="TextBox 21"/>
+          <p:cNvPr id="23" name="TextBox 22"/>
           <p:cNvSpPr txBox="1"/>
           <p:nvPr/>
         </p:nvSpPr>
@@ -12530,7 +14134,7 @@
       </p:sp>
       <p:sp>
         <p:nvSpPr>
-          <p:cNvPr id="23" name="TextBox 22"/>
+          <p:cNvPr id="24" name="TextBox 23"/>
           <p:cNvSpPr txBox="1"/>
           <p:nvPr/>
         </p:nvSpPr>
@@ -13108,8 +14712,8 @@
         </p:nvSpPr>
         <p:spPr>
           <a:xfrm>
-            <a:off x="548640" y="384048"/>
-            <a:ext cx="10058400" cy="365760"/>
+            <a:off x="548640" y="6473952"/>
+            <a:ext cx="11094415" cy="274320"/>
           </a:xfrm>
           <a:prstGeom prst="rect">
             <a:avLst/>
@@ -13117,7 +14721,7 @@
           <a:noFill/>
         </p:spPr>
         <p:txBody>
-          <a:bodyPr wrap="square" lIns="0" rIns="0" tIns="0" bIns="0" anchor="ctr">
+          <a:bodyPr wrap="square" lIns="0" rIns="0" tIns="0" bIns="0" anchor="t">
             <a:spAutoFit/>
           </a:bodyPr>
           <a:lstStyle/>
@@ -13128,13 +14732,13 @@
               </a:spcAft>
             </a:pPr>
             <a:r>
-              <a:rPr sz="1400" b="1" i="0">
-                <a:solidFill>
-                  <a:srgbClr val="E76F51"/>
+              <a:rPr sz="900" b="0" i="0">
+                <a:solidFill>
+                  <a:srgbClr val="5B6B72"/>
                 </a:solidFill>
                 <a:latin typeface="Calibri"/>
               </a:rPr>
-              <a:t>ONDE ESTAMOS E O QUE VAMOS RESPONDER</a:t>
+              <a:t>Fonte: Inep (Avaliação de Alfabetização 2023-2024, metas e resultados 2025), via Base dos Dados; Censo Escolar, IBGE e Atlas do Desenvolvimento Humano. Elaboração própria.</a:t>
             </a:r>
           </a:p>
         </p:txBody>
@@ -13147,8 +14751,8 @@
         </p:nvSpPr>
         <p:spPr>
           <a:xfrm>
-            <a:off x="548640" y="841248"/>
-            <a:ext cx="11094415" cy="731520"/>
+            <a:off x="548640" y="384048"/>
+            <a:ext cx="10058400" cy="365760"/>
           </a:xfrm>
           <a:prstGeom prst="rect">
             <a:avLst/>
@@ -13156,7 +14760,7 @@
           <a:noFill/>
         </p:spPr>
         <p:txBody>
-          <a:bodyPr wrap="square" lIns="0" rIns="0" tIns="0" bIns="0" anchor="t">
+          <a:bodyPr wrap="square" lIns="0" rIns="0" tIns="0" bIns="0" anchor="ctr">
             <a:spAutoFit/>
           </a:bodyPr>
           <a:lstStyle/>
@@ -13167,13 +14771,13 @@
               </a:spcAft>
             </a:pPr>
             <a:r>
-              <a:rPr sz="3000" b="1" i="0">
-                <a:solidFill>
-                  <a:srgbClr val="264653"/>
-                </a:solidFill>
-                <a:latin typeface="Cambria"/>
-              </a:rPr>
-              <a:t>Avançamos, mas ainda faltam 14 pontos até a meta</a:t>
+              <a:rPr sz="1400" b="1" i="0">
+                <a:solidFill>
+                  <a:srgbClr val="E76F51"/>
+                </a:solidFill>
+                <a:latin typeface="Calibri"/>
+              </a:rPr>
+              <a:t>ONDE ESTAMOS E O QUE VAMOS RESPONDER</a:t>
             </a:r>
           </a:p>
         </p:txBody>
@@ -13186,8 +14790,8 @@
         </p:nvSpPr>
         <p:spPr>
           <a:xfrm>
-            <a:off x="548640" y="1828800"/>
-            <a:ext cx="3840480" cy="777240"/>
+            <a:off x="548640" y="841248"/>
+            <a:ext cx="11094415" cy="731520"/>
           </a:xfrm>
           <a:prstGeom prst="rect">
             <a:avLst/>
@@ -13206,13 +14810,13 @@
               </a:spcAft>
             </a:pPr>
             <a:r>
-              <a:rPr sz="4400" b="1" i="0">
-                <a:solidFill>
-                  <a:srgbClr val="5B6B72"/>
+              <a:rPr sz="3000" b="1" i="0">
+                <a:solidFill>
+                  <a:srgbClr val="264653"/>
                 </a:solidFill>
                 <a:latin typeface="Cambria"/>
               </a:rPr>
-              <a:t>55,9%</a:t>
+              <a:t>Avançamos, mas ainda faltam 14 pontos até a meta</a:t>
             </a:r>
           </a:p>
         </p:txBody>
@@ -13225,8 +14829,8 @@
         </p:nvSpPr>
         <p:spPr>
           <a:xfrm>
-            <a:off x="548640" y="2578608"/>
-            <a:ext cx="3840480" cy="640080"/>
+            <a:off x="548640" y="1828800"/>
+            <a:ext cx="3840480" cy="777240"/>
           </a:xfrm>
           <a:prstGeom prst="rect">
             <a:avLst/>
@@ -13245,13 +14849,13 @@
               </a:spcAft>
             </a:pPr>
             <a:r>
-              <a:rPr sz="1300" b="0" i="0">
+              <a:rPr sz="4400" b="1" i="0">
                 <a:solidFill>
                   <a:srgbClr val="5B6B72"/>
                 </a:solidFill>
-                <a:latin typeface="Calibri"/>
-              </a:rPr>
-              <a:t>crianças alfabetizadas em 2023</a:t>
+                <a:latin typeface="Cambria"/>
+              </a:rPr>
+              <a:t>55,9%</a:t>
             </a:r>
           </a:p>
         </p:txBody>
@@ -13264,8 +14868,8 @@
         </p:nvSpPr>
         <p:spPr>
           <a:xfrm>
-            <a:off x="548640" y="3291840"/>
-            <a:ext cx="3840480" cy="777240"/>
+            <a:off x="548640" y="2578608"/>
+            <a:ext cx="3840480" cy="640080"/>
           </a:xfrm>
           <a:prstGeom prst="rect">
             <a:avLst/>
@@ -13284,13 +14888,13 @@
               </a:spcAft>
             </a:pPr>
             <a:r>
-              <a:rPr sz="4400" b="1" i="0">
-                <a:solidFill>
-                  <a:srgbClr val="264653"/>
-                </a:solidFill>
-                <a:latin typeface="Cambria"/>
-              </a:rPr>
-              <a:t>59,2%</a:t>
+              <a:rPr sz="1300" b="0" i="0">
+                <a:solidFill>
+                  <a:srgbClr val="5B6B72"/>
+                </a:solidFill>
+                <a:latin typeface="Calibri"/>
+              </a:rPr>
+              <a:t>crianças alfabetizadas em 2023</a:t>
             </a:r>
           </a:p>
         </p:txBody>
@@ -13303,8 +14907,8 @@
         </p:nvSpPr>
         <p:spPr>
           <a:xfrm>
-            <a:off x="548640" y="4041648"/>
-            <a:ext cx="3840480" cy="640080"/>
+            <a:off x="548640" y="3291840"/>
+            <a:ext cx="3840480" cy="777240"/>
           </a:xfrm>
           <a:prstGeom prst="rect">
             <a:avLst/>
@@ -13323,13 +14927,13 @@
               </a:spcAft>
             </a:pPr>
             <a:r>
-              <a:rPr sz="1300" b="0" i="0">
-                <a:solidFill>
-                  <a:srgbClr val="5B6B72"/>
-                </a:solidFill>
-                <a:latin typeface="Calibri"/>
-              </a:rPr>
-              <a:t>em 2024, abaixo da meta do ano (59,9%)</a:t>
+              <a:rPr sz="4400" b="1" i="0">
+                <a:solidFill>
+                  <a:srgbClr val="264653"/>
+                </a:solidFill>
+                <a:latin typeface="Cambria"/>
+              </a:rPr>
+              <a:t>59,2%</a:t>
             </a:r>
           </a:p>
         </p:txBody>
@@ -13342,8 +14946,8 @@
         </p:nvSpPr>
         <p:spPr>
           <a:xfrm>
-            <a:off x="548640" y="4754880"/>
-            <a:ext cx="3840480" cy="777240"/>
+            <a:off x="548640" y="4041648"/>
+            <a:ext cx="3840480" cy="640080"/>
           </a:xfrm>
           <a:prstGeom prst="rect">
             <a:avLst/>
@@ -13362,13 +14966,13 @@
               </a:spcAft>
             </a:pPr>
             <a:r>
-              <a:rPr sz="4400" b="1" i="0">
-                <a:solidFill>
-                  <a:srgbClr val="2A9D8F"/>
-                </a:solidFill>
-                <a:latin typeface="Cambria"/>
-              </a:rPr>
-              <a:t>66%</a:t>
+              <a:rPr sz="1300" b="0" i="0">
+                <a:solidFill>
+                  <a:srgbClr val="5B6B72"/>
+                </a:solidFill>
+                <a:latin typeface="Calibri"/>
+              </a:rPr>
+              <a:t>em 2024, abaixo da meta do ano (59,9%)</a:t>
             </a:r>
           </a:p>
         </p:txBody>
@@ -13381,8 +14985,8 @@
         </p:nvSpPr>
         <p:spPr>
           <a:xfrm>
-            <a:off x="548640" y="5504688"/>
-            <a:ext cx="3840480" cy="640080"/>
+            <a:off x="548640" y="4754880"/>
+            <a:ext cx="3840480" cy="777240"/>
           </a:xfrm>
           <a:prstGeom prst="rect">
             <a:avLst/>
@@ -13401,6 +15005,45 @@
               </a:spcAft>
             </a:pPr>
             <a:r>
+              <a:rPr sz="4400" b="1" i="0">
+                <a:solidFill>
+                  <a:srgbClr val="2A9D8F"/>
+                </a:solidFill>
+                <a:latin typeface="Cambria"/>
+              </a:rPr>
+              <a:t>66%</a:t>
+            </a:r>
+          </a:p>
+        </p:txBody>
+      </p:sp>
+      <p:sp>
+        <p:nvSpPr>
+          <p:cNvPr id="10" name="TextBox 9"/>
+          <p:cNvSpPr txBox="1"/>
+          <p:nvPr/>
+        </p:nvSpPr>
+        <p:spPr>
+          <a:xfrm>
+            <a:off x="548640" y="5504688"/>
+            <a:ext cx="3840480" cy="640080"/>
+          </a:xfrm>
+          <a:prstGeom prst="rect">
+            <a:avLst/>
+          </a:prstGeom>
+          <a:noFill/>
+        </p:spPr>
+        <p:txBody>
+          <a:bodyPr wrap="square" lIns="0" rIns="0" tIns="0" bIns="0" anchor="t">
+            <a:spAutoFit/>
+          </a:bodyPr>
+          <a:lstStyle/>
+          <a:p>
+            <a:pPr algn="l">
+              <a:spcAft>
+                <a:spcPts val="600"/>
+              </a:spcAft>
+            </a:pPr>
+            <a:r>
               <a:rPr sz="1300" b="0" i="0">
                 <a:solidFill>
                   <a:srgbClr val="5B6B72"/>
@@ -13414,7 +15057,7 @@
       </p:sp>
       <p:sp>
         <p:nvSpPr>
-          <p:cNvPr id="10" name="Rounded Rectangle 9"/>
+          <p:cNvPr id="11" name="Rounded Rectangle 10"/>
           <p:cNvSpPr/>
           <p:nvPr/>
         </p:nvSpPr>
@@ -13460,7 +15103,7 @@
       </p:sp>
       <p:sp>
         <p:nvSpPr>
-          <p:cNvPr id="11" name="TextBox 10"/>
+          <p:cNvPr id="12" name="TextBox 11"/>
           <p:cNvSpPr txBox="1"/>
           <p:nvPr/>
         </p:nvSpPr>
@@ -13499,7 +15142,7 @@
       </p:sp>
       <p:sp>
         <p:nvSpPr>
-          <p:cNvPr id="12" name="Oval 11"/>
+          <p:cNvPr id="13" name="Oval 12"/>
           <p:cNvSpPr/>
           <p:nvPr/>
         </p:nvSpPr>
@@ -13552,7 +15195,7 @@
       </p:sp>
       <p:sp>
         <p:nvSpPr>
-          <p:cNvPr id="13" name="TextBox 12"/>
+          <p:cNvPr id="14" name="TextBox 13"/>
           <p:cNvSpPr txBox="1"/>
           <p:nvPr/>
         </p:nvSpPr>
@@ -13591,7 +15234,7 @@
       </p:sp>
       <p:sp>
         <p:nvSpPr>
-          <p:cNvPr id="14" name="Oval 13"/>
+          <p:cNvPr id="15" name="Oval 14"/>
           <p:cNvSpPr/>
           <p:nvPr/>
         </p:nvSpPr>
@@ -13644,7 +15287,7 @@
       </p:sp>
       <p:sp>
         <p:nvSpPr>
-          <p:cNvPr id="15" name="TextBox 14"/>
+          <p:cNvPr id="16" name="TextBox 15"/>
           <p:cNvSpPr txBox="1"/>
           <p:nvPr/>
         </p:nvSpPr>
@@ -13683,7 +15326,7 @@
       </p:sp>
       <p:sp>
         <p:nvSpPr>
-          <p:cNvPr id="16" name="Oval 15"/>
+          <p:cNvPr id="17" name="Oval 16"/>
           <p:cNvSpPr/>
           <p:nvPr/>
         </p:nvSpPr>
@@ -13736,7 +15379,7 @@
       </p:sp>
       <p:sp>
         <p:nvSpPr>
-          <p:cNvPr id="17" name="TextBox 16"/>
+          <p:cNvPr id="18" name="TextBox 17"/>
           <p:cNvSpPr txBox="1"/>
           <p:nvPr/>
         </p:nvSpPr>
@@ -13775,7 +15418,7 @@
       </p:sp>
       <p:sp>
         <p:nvSpPr>
-          <p:cNvPr id="18" name="Oval 17"/>
+          <p:cNvPr id="19" name="Oval 18"/>
           <p:cNvSpPr/>
           <p:nvPr/>
         </p:nvSpPr>
@@ -13828,7 +15471,7 @@
       </p:sp>
       <p:sp>
         <p:nvSpPr>
-          <p:cNvPr id="19" name="TextBox 18"/>
+          <p:cNvPr id="20" name="TextBox 19"/>
           <p:cNvSpPr txBox="1"/>
           <p:nvPr/>
         </p:nvSpPr>
@@ -13867,7 +15510,7 @@
       </p:sp>
       <p:sp>
         <p:nvSpPr>
-          <p:cNvPr id="20" name="Oval 19"/>
+          <p:cNvPr id="21" name="Oval 20"/>
           <p:cNvSpPr/>
           <p:nvPr/>
         </p:nvSpPr>
@@ -13920,7 +15563,7 @@
       </p:sp>
       <p:sp>
         <p:nvSpPr>
-          <p:cNvPr id="21" name="TextBox 20"/>
+          <p:cNvPr id="22" name="TextBox 21"/>
           <p:cNvSpPr txBox="1"/>
           <p:nvPr/>
         </p:nvSpPr>
@@ -13983,8 +15626,8 @@
         </p:nvSpPr>
         <p:spPr>
           <a:xfrm>
-            <a:off x="548640" y="384048"/>
-            <a:ext cx="10058400" cy="365760"/>
+            <a:off x="548640" y="6473952"/>
+            <a:ext cx="11094415" cy="274320"/>
           </a:xfrm>
           <a:prstGeom prst="rect">
             <a:avLst/>
@@ -13992,7 +15635,7 @@
           <a:noFill/>
         </p:spPr>
         <p:txBody>
-          <a:bodyPr wrap="square" lIns="0" rIns="0" tIns="0" bIns="0" anchor="ctr">
+          <a:bodyPr wrap="square" lIns="0" rIns="0" tIns="0" bIns="0" anchor="t">
             <a:spAutoFit/>
           </a:bodyPr>
           <a:lstStyle/>
@@ -14003,13 +15646,13 @@
               </a:spcAft>
             </a:pPr>
             <a:r>
-              <a:rPr sz="1400" b="1" i="0">
-                <a:solidFill>
-                  <a:srgbClr val="E76F51"/>
+              <a:rPr sz="900" b="0" i="0">
+                <a:solidFill>
+                  <a:srgbClr val="5B6B72"/>
                 </a:solidFill>
                 <a:latin typeface="Calibri"/>
               </a:rPr>
-              <a:t>O PROBLEMA</a:t>
+              <a:t>Fonte: Inep (Avaliação de Alfabetização 2023-2024, metas e resultados 2025), via Base dos Dados; Censo Escolar, IBGE e Atlas do Desenvolvimento Humano. Elaboração própria.</a:t>
             </a:r>
           </a:p>
         </p:txBody>
@@ -14022,8 +15665,8 @@
         </p:nvSpPr>
         <p:spPr>
           <a:xfrm>
-            <a:off x="548640" y="841248"/>
-            <a:ext cx="11094415" cy="731520"/>
+            <a:off x="548640" y="384048"/>
+            <a:ext cx="10058400" cy="365760"/>
           </a:xfrm>
           <a:prstGeom prst="rect">
             <a:avLst/>
@@ -14031,7 +15674,7 @@
           <a:noFill/>
         </p:spPr>
         <p:txBody>
-          <a:bodyPr wrap="square" lIns="0" rIns="0" tIns="0" bIns="0" anchor="t">
+          <a:bodyPr wrap="square" lIns="0" rIns="0" tIns="0" bIns="0" anchor="ctr">
             <a:spAutoFit/>
           </a:bodyPr>
           <a:lstStyle/>
@@ -14042,6 +15685,45 @@
               </a:spcAft>
             </a:pPr>
             <a:r>
+              <a:rPr sz="1400" b="1" i="0">
+                <a:solidFill>
+                  <a:srgbClr val="E76F51"/>
+                </a:solidFill>
+                <a:latin typeface="Calibri"/>
+              </a:rPr>
+              <a:t>O PROBLEMA</a:t>
+            </a:r>
+          </a:p>
+        </p:txBody>
+      </p:sp>
+      <p:sp>
+        <p:nvSpPr>
+          <p:cNvPr id="4" name="TextBox 3"/>
+          <p:cNvSpPr txBox="1"/>
+          <p:nvPr/>
+        </p:nvSpPr>
+        <p:spPr>
+          <a:xfrm>
+            <a:off x="548640" y="841248"/>
+            <a:ext cx="11094415" cy="731520"/>
+          </a:xfrm>
+          <a:prstGeom prst="rect">
+            <a:avLst/>
+          </a:prstGeom>
+          <a:noFill/>
+        </p:spPr>
+        <p:txBody>
+          <a:bodyPr wrap="square" lIns="0" rIns="0" tIns="0" bIns="0" anchor="t">
+            <a:spAutoFit/>
+          </a:bodyPr>
+          <a:lstStyle/>
+          <a:p>
+            <a:pPr algn="l">
+              <a:spcAft>
+                <a:spcPts val="600"/>
+              </a:spcAft>
+            </a:pPr>
+            <a:r>
               <a:rPr sz="3000" b="1" i="0">
                 <a:solidFill>
                   <a:srgbClr val="264653"/>
@@ -14055,7 +15737,7 @@
       </p:sp>
       <p:graphicFrame>
         <p:nvGraphicFramePr>
-          <p:cNvPr id="4" name="Chart 3"/>
+          <p:cNvPr id="5" name="Chart 4"/>
           <p:cNvGraphicFramePr>
             <a:graphicFrameLocks noGrp="1"/>
           </p:cNvGraphicFramePr>
@@ -14073,7 +15755,7 @@
       </p:graphicFrame>
       <p:pic>
         <p:nvPicPr>
-          <p:cNvPr id="5" name="Picture 4" descr="eda_02_taxa_por_uf.png"/>
+          <p:cNvPr id="6" name="Picture 5" descr="Barras com o percentual de crianças alfabetizadas por estado em 2024, de 36% na Bahia a 85% no Ceará"/>
           <p:cNvPicPr>
             <a:picLocks noChangeAspect="1"/>
           </p:cNvPicPr>
@@ -14087,8 +15769,8 @@
         </p:blipFill>
         <p:spPr>
           <a:xfrm>
-            <a:off x="6718778" y="1691640"/>
-            <a:ext cx="4850444" cy="4846320"/>
+            <a:off x="6764537" y="1691640"/>
+            <a:ext cx="4758926" cy="4754880"/>
           </a:xfrm>
           <a:prstGeom prst="rect">
             <a:avLst/>
@@ -14121,8 +15803,8 @@
         </p:nvSpPr>
         <p:spPr>
           <a:xfrm>
-            <a:off x="548640" y="384048"/>
-            <a:ext cx="10058400" cy="365760"/>
+            <a:off x="548640" y="6473952"/>
+            <a:ext cx="11094415" cy="274320"/>
           </a:xfrm>
           <a:prstGeom prst="rect">
             <a:avLst/>
@@ -14130,7 +15812,7 @@
           <a:noFill/>
         </p:spPr>
         <p:txBody>
-          <a:bodyPr wrap="square" lIns="0" rIns="0" tIns="0" bIns="0" anchor="ctr">
+          <a:bodyPr wrap="square" lIns="0" rIns="0" tIns="0" bIns="0" anchor="t">
             <a:spAutoFit/>
           </a:bodyPr>
           <a:lstStyle/>
@@ -14141,13 +15823,13 @@
               </a:spcAft>
             </a:pPr>
             <a:r>
-              <a:rPr sz="1400" b="1" i="0">
-                <a:solidFill>
-                  <a:srgbClr val="E76F51"/>
+              <a:rPr sz="900" b="0" i="0">
+                <a:solidFill>
+                  <a:srgbClr val="5B6B72"/>
                 </a:solidFill>
                 <a:latin typeface="Calibri"/>
               </a:rPr>
-              <a:t>COMO CHEGAMOS ÀS RESPOSTAS</a:t>
+              <a:t>Fonte: Inep (Avaliação de Alfabetização 2023-2024, metas e resultados 2025), via Base dos Dados; Censo Escolar, IBGE e Atlas do Desenvolvimento Humano. Elaboração própria.</a:t>
             </a:r>
           </a:p>
         </p:txBody>
@@ -14160,8 +15842,8 @@
         </p:nvSpPr>
         <p:spPr>
           <a:xfrm>
-            <a:off x="548640" y="841248"/>
-            <a:ext cx="11094415" cy="731520"/>
+            <a:off x="548640" y="384048"/>
+            <a:ext cx="10058400" cy="365760"/>
           </a:xfrm>
           <a:prstGeom prst="rect">
             <a:avLst/>
@@ -14169,7 +15851,7 @@
           <a:noFill/>
         </p:spPr>
         <p:txBody>
-          <a:bodyPr wrap="square" lIns="0" rIns="0" tIns="0" bIns="0" anchor="t">
+          <a:bodyPr wrap="square" lIns="0" rIns="0" tIns="0" bIns="0" anchor="ctr">
             <a:spAutoFit/>
           </a:bodyPr>
           <a:lstStyle/>
@@ -14180,6 +15862,45 @@
               </a:spcAft>
             </a:pPr>
             <a:r>
+              <a:rPr sz="1400" b="1" i="0">
+                <a:solidFill>
+                  <a:srgbClr val="E76F51"/>
+                </a:solidFill>
+                <a:latin typeface="Calibri"/>
+              </a:rPr>
+              <a:t>COMO CHEGAMOS ÀS RESPOSTAS</a:t>
+            </a:r>
+          </a:p>
+        </p:txBody>
+      </p:sp>
+      <p:sp>
+        <p:nvSpPr>
+          <p:cNvPr id="4" name="TextBox 3"/>
+          <p:cNvSpPr txBox="1"/>
+          <p:nvPr/>
+        </p:nvSpPr>
+        <p:spPr>
+          <a:xfrm>
+            <a:off x="548640" y="841248"/>
+            <a:ext cx="11094415" cy="731520"/>
+          </a:xfrm>
+          <a:prstGeom prst="rect">
+            <a:avLst/>
+          </a:prstGeom>
+          <a:noFill/>
+        </p:spPr>
+        <p:txBody>
+          <a:bodyPr wrap="square" lIns="0" rIns="0" tIns="0" bIns="0" anchor="t">
+            <a:spAutoFit/>
+          </a:bodyPr>
+          <a:lstStyle/>
+          <a:p>
+            <a:pPr algn="l">
+              <a:spcAft>
+                <a:spcPts val="600"/>
+              </a:spcAft>
+            </a:pPr>
+            <a:r>
               <a:rPr sz="3000" b="1" i="0">
                 <a:solidFill>
                   <a:srgbClr val="264653"/>
@@ -14193,7 +15914,7 @@
       </p:sp>
       <p:sp>
         <p:nvSpPr>
-          <p:cNvPr id="4" name="Rounded Rectangle 3"/>
+          <p:cNvPr id="5" name="Rounded Rectangle 4"/>
           <p:cNvSpPr/>
           <p:nvPr/>
         </p:nvSpPr>
@@ -14239,7 +15960,7 @@
       </p:sp>
       <p:sp>
         <p:nvSpPr>
-          <p:cNvPr id="5" name="Oval 4"/>
+          <p:cNvPr id="6" name="Oval 5"/>
           <p:cNvSpPr/>
           <p:nvPr/>
         </p:nvSpPr>
@@ -14292,7 +16013,7 @@
       </p:sp>
       <p:sp>
         <p:nvSpPr>
-          <p:cNvPr id="6" name="TextBox 5"/>
+          <p:cNvPr id="7" name="TextBox 6"/>
           <p:cNvSpPr txBox="1"/>
           <p:nvPr/>
         </p:nvSpPr>
@@ -14331,7 +16052,7 @@
       </p:sp>
       <p:sp>
         <p:nvSpPr>
-          <p:cNvPr id="7" name="TextBox 6"/>
+          <p:cNvPr id="8" name="TextBox 7"/>
           <p:cNvSpPr txBox="1"/>
           <p:nvPr/>
         </p:nvSpPr>
@@ -14405,7 +16126,7 @@
       </p:sp>
       <p:sp>
         <p:nvSpPr>
-          <p:cNvPr id="8" name="TextBox 7"/>
+          <p:cNvPr id="9" name="TextBox 8"/>
           <p:cNvSpPr txBox="1"/>
           <p:nvPr/>
         </p:nvSpPr>
@@ -14444,7 +16165,7 @@
       </p:sp>
       <p:sp>
         <p:nvSpPr>
-          <p:cNvPr id="9" name="TextBox 8"/>
+          <p:cNvPr id="10" name="TextBox 9"/>
           <p:cNvSpPr txBox="1"/>
           <p:nvPr/>
         </p:nvSpPr>
@@ -14483,7 +16204,7 @@
       </p:sp>
       <p:sp>
         <p:nvSpPr>
-          <p:cNvPr id="10" name="Rounded Rectangle 9"/>
+          <p:cNvPr id="11" name="Rounded Rectangle 10"/>
           <p:cNvSpPr/>
           <p:nvPr/>
         </p:nvSpPr>
@@ -14529,7 +16250,7 @@
       </p:sp>
       <p:sp>
         <p:nvSpPr>
-          <p:cNvPr id="11" name="Oval 10"/>
+          <p:cNvPr id="12" name="Oval 11"/>
           <p:cNvSpPr/>
           <p:nvPr/>
         </p:nvSpPr>
@@ -14582,7 +16303,7 @@
       </p:sp>
       <p:sp>
         <p:nvSpPr>
-          <p:cNvPr id="12" name="TextBox 11"/>
+          <p:cNvPr id="13" name="TextBox 12"/>
           <p:cNvSpPr txBox="1"/>
           <p:nvPr/>
         </p:nvSpPr>
@@ -14621,7 +16342,7 @@
       </p:sp>
       <p:sp>
         <p:nvSpPr>
-          <p:cNvPr id="13" name="TextBox 12"/>
+          <p:cNvPr id="14" name="TextBox 13"/>
           <p:cNvSpPr txBox="1"/>
           <p:nvPr/>
         </p:nvSpPr>
@@ -14654,7 +16375,7 @@
                 </a:solidFill>
                 <a:latin typeface="Calibri"/>
               </a:rPr>
-              <a:t>Risco de cada criança não se alfabetizar (LightGBM)</a:t>
+              <a:t>Risco de cada criança não se alfabetizar</a:t>
             </a:r>
           </a:p>
           <a:p>
@@ -14695,7 +16416,7 @@
       </p:sp>
       <p:sp>
         <p:nvSpPr>
-          <p:cNvPr id="14" name="TextBox 13"/>
+          <p:cNvPr id="15" name="TextBox 14"/>
           <p:cNvSpPr txBox="1"/>
           <p:nvPr/>
         </p:nvSpPr>
@@ -14734,7 +16455,7 @@
       </p:sp>
       <p:sp>
         <p:nvSpPr>
-          <p:cNvPr id="15" name="TextBox 14"/>
+          <p:cNvPr id="16" name="TextBox 15"/>
           <p:cNvSpPr txBox="1"/>
           <p:nvPr/>
         </p:nvSpPr>
@@ -14773,7 +16494,7 @@
       </p:sp>
       <p:sp>
         <p:nvSpPr>
-          <p:cNvPr id="16" name="Rounded Rectangle 15"/>
+          <p:cNvPr id="17" name="Rounded Rectangle 16"/>
           <p:cNvSpPr/>
           <p:nvPr/>
         </p:nvSpPr>
@@ -14819,7 +16540,7 @@
       </p:sp>
       <p:sp>
         <p:nvSpPr>
-          <p:cNvPr id="17" name="Oval 16"/>
+          <p:cNvPr id="18" name="Oval 17"/>
           <p:cNvSpPr/>
           <p:nvPr/>
         </p:nvSpPr>
@@ -14872,7 +16593,7 @@
       </p:sp>
       <p:sp>
         <p:nvSpPr>
-          <p:cNvPr id="18" name="TextBox 17"/>
+          <p:cNvPr id="19" name="TextBox 18"/>
           <p:cNvSpPr txBox="1"/>
           <p:nvPr/>
         </p:nvSpPr>
@@ -14911,7 +16632,7 @@
       </p:sp>
       <p:sp>
         <p:nvSpPr>
-          <p:cNvPr id="19" name="TextBox 18"/>
+          <p:cNvPr id="20" name="TextBox 19"/>
           <p:cNvSpPr txBox="1"/>
           <p:nvPr/>
         </p:nvSpPr>
@@ -14985,7 +16706,7 @@
       </p:sp>
       <p:sp>
         <p:nvSpPr>
-          <p:cNvPr id="20" name="TextBox 19"/>
+          <p:cNvPr id="21" name="TextBox 20"/>
           <p:cNvSpPr txBox="1"/>
           <p:nvPr/>
         </p:nvSpPr>
@@ -15024,7 +16745,7 @@
       </p:sp>
       <p:sp>
         <p:nvSpPr>
-          <p:cNvPr id="21" name="TextBox 20"/>
+          <p:cNvPr id="22" name="TextBox 21"/>
           <p:cNvSpPr txBox="1"/>
           <p:nvPr/>
         </p:nvSpPr>
@@ -15081,7 +16802,46 @@
       <p:grpSpPr/>
       <p:sp>
         <p:nvSpPr>
-          <p:cNvPr id="2" name="Oval 1"/>
+          <p:cNvPr id="2" name="TextBox 1"/>
+          <p:cNvSpPr txBox="1"/>
+          <p:nvPr/>
+        </p:nvSpPr>
+        <p:spPr>
+          <a:xfrm>
+            <a:off x="548640" y="6473952"/>
+            <a:ext cx="11094415" cy="274320"/>
+          </a:xfrm>
+          <a:prstGeom prst="rect">
+            <a:avLst/>
+          </a:prstGeom>
+          <a:noFill/>
+        </p:spPr>
+        <p:txBody>
+          <a:bodyPr wrap="square" lIns="0" rIns="0" tIns="0" bIns="0" anchor="t">
+            <a:spAutoFit/>
+          </a:bodyPr>
+          <a:lstStyle/>
+          <a:p>
+            <a:pPr algn="l">
+              <a:spcAft>
+                <a:spcPts val="600"/>
+              </a:spcAft>
+            </a:pPr>
+            <a:r>
+              <a:rPr sz="900" b="0" i="0">
+                <a:solidFill>
+                  <a:srgbClr val="5B6B72"/>
+                </a:solidFill>
+                <a:latin typeface="Calibri"/>
+              </a:rPr>
+              <a:t>Fonte: Inep (Avaliação de Alfabetização 2023-2024, metas e resultados 2025), via Base dos Dados; Censo Escolar, IBGE e Atlas do Desenvolvimento Humano. Elaboração própria.</a:t>
+            </a:r>
+          </a:p>
+        </p:txBody>
+      </p:sp>
+      <p:sp>
+        <p:nvSpPr>
+          <p:cNvPr id="3" name="Oval 2"/>
           <p:cNvSpPr/>
           <p:nvPr/>
         </p:nvSpPr>
@@ -15134,7 +16894,7 @@
       </p:sp>
       <p:sp>
         <p:nvSpPr>
-          <p:cNvPr id="3" name="TextBox 2"/>
+          <p:cNvPr id="4" name="TextBox 3"/>
           <p:cNvSpPr txBox="1"/>
           <p:nvPr/>
         </p:nvSpPr>
@@ -15173,7 +16933,7 @@
       </p:sp>
       <p:sp>
         <p:nvSpPr>
-          <p:cNvPr id="4" name="TextBox 3"/>
+          <p:cNvPr id="5" name="TextBox 4"/>
           <p:cNvSpPr txBox="1"/>
           <p:nvPr/>
         </p:nvSpPr>
@@ -15212,7 +16972,7 @@
       </p:sp>
       <p:sp>
         <p:nvSpPr>
-          <p:cNvPr id="5" name="TextBox 4"/>
+          <p:cNvPr id="6" name="TextBox 5"/>
           <p:cNvSpPr txBox="1"/>
           <p:nvPr/>
         </p:nvSpPr>
@@ -15260,7 +17020,7 @@
       </p:sp>
       <p:graphicFrame>
         <p:nvGraphicFramePr>
-          <p:cNvPr id="6" name="Chart 5"/>
+          <p:cNvPr id="7" name="Chart 6"/>
           <p:cNvGraphicFramePr>
             <a:graphicFrameLocks noGrp="1"/>
           </p:cNvGraphicFramePr>
@@ -15278,7 +17038,7 @@
       </p:graphicFrame>
       <p:sp>
         <p:nvSpPr>
-          <p:cNvPr id="7" name="Rounded Rectangle 6"/>
+          <p:cNvPr id="8" name="Rounded Rectangle 7"/>
           <p:cNvSpPr/>
           <p:nvPr/>
         </p:nvSpPr>
@@ -15324,7 +17084,7 @@
       </p:sp>
       <p:sp>
         <p:nvSpPr>
-          <p:cNvPr id="8" name="TextBox 7"/>
+          <p:cNvPr id="9" name="TextBox 8"/>
           <p:cNvSpPr txBox="1"/>
           <p:nvPr/>
         </p:nvSpPr>
@@ -15460,7 +17220,46 @@
       <p:grpSpPr/>
       <p:sp>
         <p:nvSpPr>
-          <p:cNvPr id="2" name="Oval 1"/>
+          <p:cNvPr id="2" name="TextBox 1"/>
+          <p:cNvSpPr txBox="1"/>
+          <p:nvPr/>
+        </p:nvSpPr>
+        <p:spPr>
+          <a:xfrm>
+            <a:off x="548640" y="6473952"/>
+            <a:ext cx="11094415" cy="274320"/>
+          </a:xfrm>
+          <a:prstGeom prst="rect">
+            <a:avLst/>
+          </a:prstGeom>
+          <a:noFill/>
+        </p:spPr>
+        <p:txBody>
+          <a:bodyPr wrap="square" lIns="0" rIns="0" tIns="0" bIns="0" anchor="t">
+            <a:spAutoFit/>
+          </a:bodyPr>
+          <a:lstStyle/>
+          <a:p>
+            <a:pPr algn="l">
+              <a:spcAft>
+                <a:spcPts val="600"/>
+              </a:spcAft>
+            </a:pPr>
+            <a:r>
+              <a:rPr sz="900" b="0" i="0">
+                <a:solidFill>
+                  <a:srgbClr val="5B6B72"/>
+                </a:solidFill>
+                <a:latin typeface="Calibri"/>
+              </a:rPr>
+              <a:t>Fonte: Inep (Avaliação de Alfabetização 2023-2024, metas e resultados 2025), via Base dos Dados; Censo Escolar, IBGE e Atlas do Desenvolvimento Humano. Elaboração própria.</a:t>
+            </a:r>
+          </a:p>
+        </p:txBody>
+      </p:sp>
+      <p:sp>
+        <p:nvSpPr>
+          <p:cNvPr id="3" name="Oval 2"/>
           <p:cNvSpPr/>
           <p:nvPr/>
         </p:nvSpPr>
@@ -15513,7 +17312,7 @@
       </p:sp>
       <p:sp>
         <p:nvSpPr>
-          <p:cNvPr id="3" name="TextBox 2"/>
+          <p:cNvPr id="4" name="TextBox 3"/>
           <p:cNvSpPr txBox="1"/>
           <p:nvPr/>
         </p:nvSpPr>
@@ -15552,7 +17351,7 @@
       </p:sp>
       <p:sp>
         <p:nvSpPr>
-          <p:cNvPr id="4" name="TextBox 3"/>
+          <p:cNvPr id="5" name="TextBox 4"/>
           <p:cNvSpPr txBox="1"/>
           <p:nvPr/>
         </p:nvSpPr>
@@ -15591,7 +17390,7 @@
       </p:sp>
       <p:sp>
         <p:nvSpPr>
-          <p:cNvPr id="5" name="TextBox 4"/>
+          <p:cNvPr id="6" name="TextBox 5"/>
           <p:cNvSpPr txBox="1"/>
           <p:nvPr/>
         </p:nvSpPr>
@@ -15630,7 +17429,7 @@
       </p:sp>
       <p:sp>
         <p:nvSpPr>
-          <p:cNvPr id="6" name="TextBox 5"/>
+          <p:cNvPr id="7" name="TextBox 6"/>
           <p:cNvSpPr txBox="1"/>
           <p:nvPr/>
         </p:nvSpPr>
@@ -15669,7 +17468,7 @@
       </p:sp>
       <p:sp>
         <p:nvSpPr>
-          <p:cNvPr id="7" name="TextBox 6"/>
+          <p:cNvPr id="8" name="TextBox 7"/>
           <p:cNvSpPr txBox="1"/>
           <p:nvPr/>
         </p:nvSpPr>
@@ -15708,7 +17507,7 @@
       </p:sp>
       <p:sp>
         <p:nvSpPr>
-          <p:cNvPr id="8" name="TextBox 7"/>
+          <p:cNvPr id="9" name="TextBox 8"/>
           <p:cNvSpPr txBox="1"/>
           <p:nvPr/>
         </p:nvSpPr>
@@ -15747,7 +17546,7 @@
       </p:sp>
       <p:sp>
         <p:nvSpPr>
-          <p:cNvPr id="9" name="Rounded Rectangle 8"/>
+          <p:cNvPr id="10" name="Rounded Rectangle 9"/>
           <p:cNvSpPr/>
           <p:nvPr/>
         </p:nvSpPr>
@@ -15793,7 +17592,7 @@
       </p:sp>
       <p:sp>
         <p:nvSpPr>
-          <p:cNvPr id="10" name="TextBox 9"/>
+          <p:cNvPr id="11" name="TextBox 10"/>
           <p:cNvSpPr txBox="1"/>
           <p:nvPr/>
         </p:nvSpPr>
@@ -15832,7 +17631,7 @@
       </p:sp>
       <p:sp>
         <p:nvSpPr>
-          <p:cNvPr id="11" name="TextBox 10"/>
+          <p:cNvPr id="12" name="TextBox 11"/>
           <p:cNvSpPr txBox="1"/>
           <p:nvPr/>
         </p:nvSpPr>
@@ -15904,30 +17703,63 @@
           </a:p>
         </p:txBody>
       </p:sp>
-      <p:pic>
-        <p:nvPicPr>
-          <p:cNvPr id="12" name="Picture 11" descr="int_09_local_menor_risco.png"/>
-          <p:cNvPicPr>
-            <a:picLocks noChangeAspect="1"/>
-          </p:cNvPicPr>
-          <p:nvPr/>
-        </p:nvPicPr>
-        <p:blipFill>
-          <a:blip r:embed="rId2"/>
-          <a:stretch>
-            <a:fillRect/>
-          </a:stretch>
-        </p:blipFill>
-        <p:spPr>
-          <a:xfrm>
-            <a:off x="5760720" y="2145868"/>
-            <a:ext cx="5897880" cy="3754983"/>
+      <p:graphicFrame>
+        <p:nvGraphicFramePr>
+          <p:cNvPr id="13" name="Chart 12"/>
+          <p:cNvGraphicFramePr>
+            <a:graphicFrameLocks noGrp="1"/>
+          </p:cNvGraphicFramePr>
+          <p:nvPr/>
+        </p:nvGraphicFramePr>
+        <p:xfrm>
+          <a:off x="5760720" y="1783080"/>
+          <a:ext cx="5852160" cy="4023360"/>
+        </p:xfrm>
+        <a:graphic>
+          <a:graphicData uri="http://schemas.openxmlformats.org/drawingml/2006/chart">
+            <c:chart xmlns:c="http://schemas.openxmlformats.org/drawingml/2006/chart" r:id="rId2"/>
+          </a:graphicData>
+        </a:graphic>
+      </p:graphicFrame>
+      <p:sp>
+        <p:nvSpPr>
+          <p:cNvPr id="14" name="TextBox 13"/>
+          <p:cNvSpPr txBox="1"/>
+          <p:nvPr/>
+        </p:nvSpPr>
+        <p:spPr>
+          <a:xfrm>
+            <a:off x="5760720" y="5897880"/>
+            <a:ext cx="5852160" cy="457200"/>
           </a:xfrm>
           <a:prstGeom prst="rect">
             <a:avLst/>
           </a:prstGeom>
-        </p:spPr>
-      </p:pic>
+          <a:noFill/>
+        </p:spPr>
+        <p:txBody>
+          <a:bodyPr wrap="square" lIns="0" rIns="0" tIns="0" bIns="0" anchor="t">
+            <a:spAutoFit/>
+          </a:bodyPr>
+          <a:lstStyle/>
+          <a:p>
+            <a:pPr algn="l">
+              <a:spcAft>
+                <a:spcPts val="600"/>
+              </a:spcAft>
+            </a:pPr>
+            <a:r>
+              <a:rPr sz="1200" b="0" i="1">
+                <a:solidFill>
+                  <a:srgbClr val="5B6B72"/>
+                </a:solidFill>
+                <a:latin typeface="Calibri"/>
+              </a:rPr>
+              <a:t>É a rede de menor risco previsto entre 20 mil alunos analisados: o caso extremo, usado como ilustração.</a:t>
+            </a:r>
+          </a:p>
+        </p:txBody>
+      </p:sp>
     </p:spTree>
   </p:cSld>
   <p:clrMapOvr>
@@ -15948,7 +17780,46 @@
       <p:grpSpPr/>
       <p:sp>
         <p:nvSpPr>
-          <p:cNvPr id="2" name="Oval 1"/>
+          <p:cNvPr id="2" name="TextBox 1"/>
+          <p:cNvSpPr txBox="1"/>
+          <p:nvPr/>
+        </p:nvSpPr>
+        <p:spPr>
+          <a:xfrm>
+            <a:off x="548640" y="6473952"/>
+            <a:ext cx="11094415" cy="274320"/>
+          </a:xfrm>
+          <a:prstGeom prst="rect">
+            <a:avLst/>
+          </a:prstGeom>
+          <a:noFill/>
+        </p:spPr>
+        <p:txBody>
+          <a:bodyPr wrap="square" lIns="0" rIns="0" tIns="0" bIns="0" anchor="t">
+            <a:spAutoFit/>
+          </a:bodyPr>
+          <a:lstStyle/>
+          <a:p>
+            <a:pPr algn="l">
+              <a:spcAft>
+                <a:spcPts val="600"/>
+              </a:spcAft>
+            </a:pPr>
+            <a:r>
+              <a:rPr sz="900" b="0" i="0">
+                <a:solidFill>
+                  <a:srgbClr val="5B6B72"/>
+                </a:solidFill>
+                <a:latin typeface="Calibri"/>
+              </a:rPr>
+              <a:t>Fonte: Inep (Avaliação de Alfabetização 2023-2024, metas e resultados 2025), via Base dos Dados; Censo Escolar, IBGE e Atlas do Desenvolvimento Humano. Elaboração própria.</a:t>
+            </a:r>
+          </a:p>
+        </p:txBody>
+      </p:sp>
+      <p:sp>
+        <p:nvSpPr>
+          <p:cNvPr id="3" name="Oval 2"/>
           <p:cNvSpPr/>
           <p:nvPr/>
         </p:nvSpPr>
@@ -16001,7 +17872,7 @@
       </p:sp>
       <p:sp>
         <p:nvSpPr>
-          <p:cNvPr id="3" name="TextBox 2"/>
+          <p:cNvPr id="4" name="TextBox 3"/>
           <p:cNvSpPr txBox="1"/>
           <p:nvPr/>
         </p:nvSpPr>
@@ -16040,7 +17911,7 @@
       </p:sp>
       <p:sp>
         <p:nvSpPr>
-          <p:cNvPr id="4" name="TextBox 3"/>
+          <p:cNvPr id="5" name="TextBox 4"/>
           <p:cNvSpPr txBox="1"/>
           <p:nvPr/>
         </p:nvSpPr>
@@ -16079,7 +17950,7 @@
       </p:sp>
       <p:sp>
         <p:nvSpPr>
-          <p:cNvPr id="5" name="TextBox 4"/>
+          <p:cNvPr id="6" name="TextBox 5"/>
           <p:cNvSpPr txBox="1"/>
           <p:nvPr/>
         </p:nvSpPr>
@@ -16127,7 +17998,7 @@
       </p:sp>
       <p:graphicFrame>
         <p:nvGraphicFramePr>
-          <p:cNvPr id="6" name="Chart 5"/>
+          <p:cNvPr id="7" name="Chart 6"/>
           <p:cNvGraphicFramePr>
             <a:graphicFrameLocks noGrp="1"/>
           </p:cNvGraphicFramePr>
@@ -16145,7 +18016,7 @@
       </p:graphicFrame>
       <p:sp>
         <p:nvSpPr>
-          <p:cNvPr id="7" name="Rounded Rectangle 6"/>
+          <p:cNvPr id="8" name="Rounded Rectangle 7"/>
           <p:cNvSpPr/>
           <p:nvPr/>
         </p:nvSpPr>
@@ -16191,7 +18062,7 @@
       </p:sp>
       <p:sp>
         <p:nvSpPr>
-          <p:cNvPr id="8" name="TextBox 7"/>
+          <p:cNvPr id="9" name="TextBox 8"/>
           <p:cNvSpPr txBox="1"/>
           <p:nvPr/>
         </p:nvSpPr>
@@ -16223,14 +18094,14 @@
                 </a:solidFill>
                 <a:latin typeface="Calibri"/>
               </a:rPr>
-              <a:t>Duas técnicas, o mesmo ranking</a:t>
-            </a:r>
-          </a:p>
-        </p:txBody>
-      </p:sp>
-      <p:sp>
-        <p:nvSpPr>
-          <p:cNvPr id="9" name="TextBox 8"/>
+              <a:t>Dois testes, o mesmo ranking</a:t>
+            </a:r>
+          </a:p>
+        </p:txBody>
+      </p:sp>
+      <p:sp>
+        <p:nvSpPr>
+          <p:cNvPr id="10" name="TextBox 9"/>
           <p:cNvSpPr txBox="1"/>
           <p:nvPr/>
         </p:nvSpPr>
@@ -16263,7 +18134,7 @@
                 </a:solidFill>
                 <a:latin typeface="Calibri"/>
               </a:rPr>
-              <a:t>SHAP: </a:t>
+              <a:t>Leitura da previsão: </a:t>
             </a:r>
             <a:r>
               <a:rPr sz="1400" b="0" i="0">
@@ -16272,7 +18143,7 @@
                 </a:solidFill>
                 <a:latin typeface="Calibri"/>
               </a:rPr>
-              <a:t>quanto cada variável move a previsão de cada criança</a:t>
+              <a:t>quanto cada variável empurra a chance de cada criança</a:t>
             </a:r>
           </a:p>
           <a:p>
@@ -16289,7 +18160,7 @@
                 </a:solidFill>
                 <a:latin typeface="Calibri"/>
               </a:rPr>
-              <a:t>Permutação: </a:t>
+              <a:t>Teste de retirada: </a:t>
             </a:r>
             <a:r>
               <a:rPr sz="1400" b="0" i="0">
@@ -16298,7 +18169,7 @@
                 </a:solidFill>
                 <a:latin typeface="Calibri"/>
               </a:rPr>
-              <a:t>quanto o acerto cai sem a variável; o estado sozinho tira 0,037 do AUC</a:t>
+              <a:t>sem o estado, o modelo perde mais acerto do que sem qualquer outra variável</a:t>
             </a:r>
           </a:p>
           <a:p>
@@ -16340,7 +18211,46 @@
       <p:grpSpPr/>
       <p:sp>
         <p:nvSpPr>
-          <p:cNvPr id="2" name="Oval 1"/>
+          <p:cNvPr id="2" name="TextBox 1"/>
+          <p:cNvSpPr txBox="1"/>
+          <p:nvPr/>
+        </p:nvSpPr>
+        <p:spPr>
+          <a:xfrm>
+            <a:off x="548640" y="6473952"/>
+            <a:ext cx="11094415" cy="274320"/>
+          </a:xfrm>
+          <a:prstGeom prst="rect">
+            <a:avLst/>
+          </a:prstGeom>
+          <a:noFill/>
+        </p:spPr>
+        <p:txBody>
+          <a:bodyPr wrap="square" lIns="0" rIns="0" tIns="0" bIns="0" anchor="t">
+            <a:spAutoFit/>
+          </a:bodyPr>
+          <a:lstStyle/>
+          <a:p>
+            <a:pPr algn="l">
+              <a:spcAft>
+                <a:spcPts val="600"/>
+              </a:spcAft>
+            </a:pPr>
+            <a:r>
+              <a:rPr sz="900" b="0" i="0">
+                <a:solidFill>
+                  <a:srgbClr val="5B6B72"/>
+                </a:solidFill>
+                <a:latin typeface="Calibri"/>
+              </a:rPr>
+              <a:t>Fonte: Inep (Avaliação de Alfabetização 2023-2024, metas e resultados 2025), via Base dos Dados; Censo Escolar, IBGE e Atlas do Desenvolvimento Humano. Elaboração própria.</a:t>
+            </a:r>
+          </a:p>
+        </p:txBody>
+      </p:sp>
+      <p:sp>
+        <p:nvSpPr>
+          <p:cNvPr id="3" name="Oval 2"/>
           <p:cNvSpPr/>
           <p:nvPr/>
         </p:nvSpPr>
@@ -16393,7 +18303,7 @@
       </p:sp>
       <p:sp>
         <p:nvSpPr>
-          <p:cNvPr id="3" name="TextBox 2"/>
+          <p:cNvPr id="4" name="TextBox 3"/>
           <p:cNvSpPr txBox="1"/>
           <p:nvPr/>
         </p:nvSpPr>
@@ -16432,7 +18342,7 @@
       </p:sp>
       <p:sp>
         <p:nvSpPr>
-          <p:cNvPr id="4" name="TextBox 3"/>
+          <p:cNvPr id="5" name="TextBox 4"/>
           <p:cNvSpPr txBox="1"/>
           <p:nvPr/>
         </p:nvSpPr>
@@ -16469,33 +18379,27 @@
           </a:p>
         </p:txBody>
       </p:sp>
-      <p:pic>
-        <p:nvPicPr>
-          <p:cNvPr id="5" name="Picture 4" descr="int_05_efeito_uf.png"/>
-          <p:cNvPicPr>
-            <a:picLocks noChangeAspect="1"/>
-          </p:cNvPicPr>
-          <p:nvPr/>
-        </p:nvPicPr>
-        <p:blipFill>
-          <a:blip r:embed="rId2"/>
-          <a:stretch>
-            <a:fillRect/>
-          </a:stretch>
-        </p:blipFill>
-        <p:spPr>
-          <a:xfrm>
-            <a:off x="596716" y="1691640"/>
-            <a:ext cx="5024488" cy="4892040"/>
-          </a:xfrm>
-          <a:prstGeom prst="rect">
-            <a:avLst/>
-          </a:prstGeom>
-        </p:spPr>
-      </p:pic>
-      <p:sp>
-        <p:nvSpPr>
-          <p:cNvPr id="6" name="TextBox 5"/>
+      <p:graphicFrame>
+        <p:nvGraphicFramePr>
+          <p:cNvPr id="6" name="Chart 5"/>
+          <p:cNvGraphicFramePr>
+            <a:graphicFrameLocks noGrp="1"/>
+          </p:cNvGraphicFramePr>
+          <p:nvPr/>
+        </p:nvGraphicFramePr>
+        <p:xfrm>
+          <a:off x="548640" y="1783080"/>
+          <a:ext cx="5120640" cy="4572000"/>
+        </p:xfrm>
+        <a:graphic>
+          <a:graphicData uri="http://schemas.openxmlformats.org/drawingml/2006/chart">
+            <c:chart xmlns:c="http://schemas.openxmlformats.org/drawingml/2006/chart" r:id="rId2"/>
+          </a:graphicData>
+        </a:graphic>
+      </p:graphicFrame>
+      <p:sp>
+        <p:nvSpPr>
+          <p:cNvPr id="7" name="TextBox 6"/>
           <p:cNvSpPr txBox="1"/>
           <p:nvPr/>
         </p:nvSpPr>
@@ -16534,7 +18438,7 @@
       </p:sp>
       <p:sp>
         <p:nvSpPr>
-          <p:cNvPr id="7" name="TextBox 6"/>
+          <p:cNvPr id="8" name="TextBox 7"/>
           <p:cNvSpPr txBox="1"/>
           <p:nvPr/>
         </p:nvSpPr>
@@ -16608,7 +18512,7 @@
       </p:sp>
       <p:sp>
         <p:nvSpPr>
-          <p:cNvPr id="8" name="TextBox 7"/>
+          <p:cNvPr id="9" name="TextBox 8"/>
           <p:cNvSpPr txBox="1"/>
           <p:nvPr/>
         </p:nvSpPr>
@@ -16647,7 +18551,7 @@
       </p:sp>
       <p:sp>
         <p:nvSpPr>
-          <p:cNvPr id="9" name="Rounded Rectangle 8"/>
+          <p:cNvPr id="10" name="Rounded Rectangle 9"/>
           <p:cNvSpPr/>
           <p:nvPr/>
         </p:nvSpPr>
@@ -16693,7 +18597,7 @@
       </p:sp>
       <p:sp>
         <p:nvSpPr>
-          <p:cNvPr id="10" name="TextBox 9"/>
+          <p:cNvPr id="11" name="TextBox 10"/>
           <p:cNvSpPr txBox="1"/>
           <p:nvPr/>
         </p:nvSpPr>
@@ -16732,7 +18636,7 @@
       </p:sp>
       <p:sp>
         <p:nvSpPr>
-          <p:cNvPr id="11" name="TextBox 10"/>
+          <p:cNvPr id="12" name="TextBox 11"/>
           <p:cNvSpPr txBox="1"/>
           <p:nvPr/>
         </p:nvSpPr>
@@ -16771,7 +18675,7 @@
       </p:sp>
       <p:sp>
         <p:nvSpPr>
-          <p:cNvPr id="12" name="Rounded Rectangle 11"/>
+          <p:cNvPr id="13" name="Rounded Rectangle 12"/>
           <p:cNvSpPr/>
           <p:nvPr/>
         </p:nvSpPr>
@@ -16817,7 +18721,7 @@
       </p:sp>
       <p:sp>
         <p:nvSpPr>
-          <p:cNvPr id="13" name="TextBox 12"/>
+          <p:cNvPr id="14" name="TextBox 13"/>
           <p:cNvSpPr txBox="1"/>
           <p:nvPr/>
         </p:nvSpPr>
@@ -16856,7 +18760,7 @@
       </p:sp>
       <p:sp>
         <p:nvSpPr>
-          <p:cNvPr id="14" name="TextBox 13"/>
+          <p:cNvPr id="15" name="TextBox 14"/>
           <p:cNvSpPr txBox="1"/>
           <p:nvPr/>
         </p:nvSpPr>
@@ -16895,7 +18799,7 @@
       </p:sp>
       <p:sp>
         <p:nvSpPr>
-          <p:cNvPr id="15" name="Rounded Rectangle 14"/>
+          <p:cNvPr id="16" name="Rounded Rectangle 15"/>
           <p:cNvSpPr/>
           <p:nvPr/>
         </p:nvSpPr>
@@ -16941,7 +18845,7 @@
       </p:sp>
       <p:sp>
         <p:nvSpPr>
-          <p:cNvPr id="16" name="TextBox 15"/>
+          <p:cNvPr id="17" name="TextBox 16"/>
           <p:cNvSpPr txBox="1"/>
           <p:nvPr/>
         </p:nvSpPr>
@@ -16980,7 +18884,7 @@
       </p:sp>
       <p:sp>
         <p:nvSpPr>
-          <p:cNvPr id="17" name="TextBox 16"/>
+          <p:cNvPr id="18" name="TextBox 17"/>
           <p:cNvSpPr txBox="1"/>
           <p:nvPr/>
         </p:nvSpPr>
@@ -17037,7 +18941,46 @@
       <p:grpSpPr/>
       <p:sp>
         <p:nvSpPr>
-          <p:cNvPr id="2" name="Oval 1"/>
+          <p:cNvPr id="2" name="TextBox 1"/>
+          <p:cNvSpPr txBox="1"/>
+          <p:nvPr/>
+        </p:nvSpPr>
+        <p:spPr>
+          <a:xfrm>
+            <a:off x="548640" y="6473952"/>
+            <a:ext cx="11094415" cy="274320"/>
+          </a:xfrm>
+          <a:prstGeom prst="rect">
+            <a:avLst/>
+          </a:prstGeom>
+          <a:noFill/>
+        </p:spPr>
+        <p:txBody>
+          <a:bodyPr wrap="square" lIns="0" rIns="0" tIns="0" bIns="0" anchor="t">
+            <a:spAutoFit/>
+          </a:bodyPr>
+          <a:lstStyle/>
+          <a:p>
+            <a:pPr algn="l">
+              <a:spcAft>
+                <a:spcPts val="600"/>
+              </a:spcAft>
+            </a:pPr>
+            <a:r>
+              <a:rPr sz="900" b="0" i="0">
+                <a:solidFill>
+                  <a:srgbClr val="5B6B72"/>
+                </a:solidFill>
+                <a:latin typeface="Calibri"/>
+              </a:rPr>
+              <a:t>Fonte: Inep (Avaliação de Alfabetização 2023-2024, metas e resultados 2025), via Base dos Dados; Censo Escolar, IBGE e Atlas do Desenvolvimento Humano. Elaboração própria.</a:t>
+            </a:r>
+          </a:p>
+        </p:txBody>
+      </p:sp>
+      <p:sp>
+        <p:nvSpPr>
+          <p:cNvPr id="3" name="Oval 2"/>
           <p:cNvSpPr/>
           <p:nvPr/>
         </p:nvSpPr>
@@ -17090,7 +19033,7 @@
       </p:sp>
       <p:sp>
         <p:nvSpPr>
-          <p:cNvPr id="3" name="TextBox 2"/>
+          <p:cNvPr id="4" name="TextBox 3"/>
           <p:cNvSpPr txBox="1"/>
           <p:nvPr/>
         </p:nvSpPr>
@@ -17129,7 +19072,7 @@
       </p:sp>
       <p:sp>
         <p:nvSpPr>
-          <p:cNvPr id="4" name="TextBox 3"/>
+          <p:cNvPr id="5" name="TextBox 4"/>
           <p:cNvSpPr txBox="1"/>
           <p:nvPr/>
         </p:nvSpPr>
@@ -17168,7 +19111,7 @@
       </p:sp>
       <p:sp>
         <p:nvSpPr>
-          <p:cNvPr id="5" name="TextBox 4"/>
+          <p:cNvPr id="6" name="TextBox 5"/>
           <p:cNvSpPr txBox="1"/>
           <p:nvPr/>
         </p:nvSpPr>
@@ -17216,7 +19159,7 @@
       </p:sp>
       <p:pic>
         <p:nvPicPr>
-          <p:cNvPr id="6" name="Picture 5" descr="_mapa_grupos.png"/>
+          <p:cNvPr id="7" name="Picture 6" descr="Mapa do Brasil com cada município colorido pelo seu grupo de contexto"/>
           <p:cNvPicPr>
             <a:picLocks noChangeAspect="1"/>
           </p:cNvPicPr>
@@ -17230,8 +19173,8 @@
         </p:blipFill>
         <p:spPr>
           <a:xfrm>
-            <a:off x="618183" y="2103120"/>
-            <a:ext cx="4341474" cy="4434840"/>
+            <a:off x="548640" y="2133786"/>
+            <a:ext cx="4480560" cy="4144908"/>
           </a:xfrm>
           <a:prstGeom prst="rect">
             <a:avLst/>
@@ -17240,7 +19183,7 @@
       </p:pic>
       <p:graphicFrame>
         <p:nvGraphicFramePr>
-          <p:cNvPr id="7" name="Chart 6"/>
+          <p:cNvPr id="8" name="Chart 7"/>
           <p:cNvGraphicFramePr>
             <a:graphicFrameLocks noGrp="1"/>
           </p:cNvGraphicFramePr>
@@ -17258,7 +19201,7 @@
       </p:graphicFrame>
       <p:sp>
         <p:nvSpPr>
-          <p:cNvPr id="8" name="Rounded Rectangle 7"/>
+          <p:cNvPr id="9" name="Rounded Rectangle 8"/>
           <p:cNvSpPr/>
           <p:nvPr/>
         </p:nvSpPr>
@@ -17304,7 +19247,7 @@
       </p:sp>
       <p:sp>
         <p:nvSpPr>
-          <p:cNvPr id="9" name="TextBox 8"/>
+          <p:cNvPr id="10" name="TextBox 9"/>
           <p:cNvSpPr txBox="1"/>
           <p:nvPr/>
         </p:nvSpPr>

</xml_diff>